<commit_message>
Focus operations slide on safeguards and human oversight
</commit_message>
<xml_diff>
--- a/presentation/atlas_factored_hackathon_2026.pptx
+++ b/presentation/atlas_factored_hackathon_2026.pptx
@@ -8332,7 +8332,7 @@
                 </a:solidFill>
                 <a:latin typeface="Arial"/>
               </a:rPr>
-              <a:t>Built with limits, checks, and a safe fallback</a:t>
+              <a:t>Built with controlled actions and a safe fallback</a:t>
             </a:r>
           </a:p>
         </p:txBody>
@@ -8374,7 +8374,7 @@
                 </a:solidFill>
                 <a:latin typeface="Arial"/>
               </a:rPr>
-              <a:t>The demo is deployed; the measured evidence is deliberately narrower than a production claim.</a:t>
+              <a:t>The deployed demo keeps customer data, model answers, and verified actions within distinct boundaries.</a:t>
             </a:r>
           </a:p>
         </p:txBody>
@@ -9062,7 +9062,7 @@
                 </a:solidFill>
                 <a:latin typeface="Arial"/>
               </a:rPr>
-              <a:t>Scalability + cost</a:t>
+              <a:t>Scalability</a:t>
             </a:r>
           </a:p>
         </p:txBody>
@@ -9104,7 +9104,7 @@
                 </a:solidFill>
                 <a:latin typeface="Arial"/>
               </a:rPr>
-              <a:t>Lambda + on-demand DynamoDB; shared 200 model</a:t>
+              <a:t>Lambda + on-demand DynamoDB keep compute and state</a:t>
             </a:r>
           </a:p>
           <a:p>
@@ -9123,7 +9123,7 @@
                 </a:solidFill>
                 <a:latin typeface="Arial"/>
               </a:rPr>
-              <a:t>attempts/day. Six-visitor check: 24/24 requests.</a:t>
+              <a:t>separate. Shared sessions support concurrent requests.</a:t>
             </a:r>
           </a:p>
           <a:p>
@@ -9142,7 +9142,7 @@
                 </a:solidFill>
                 <a:latin typeface="Arial"/>
               </a:rPr>
-              <a:t>Regional Lambda concurrency quota: 10; no peak test.</a:t>
+              <a:t>Six-visitor check: 24/24 requests; no peak load test.</a:t>
             </a:r>
           </a:p>
         </p:txBody>
@@ -9318,7 +9318,7 @@
                 </a:solidFill>
                 <a:latin typeface="Arial"/>
               </a:rPr>
-              <a:t>Quality + baseline</a:t>
+              <a:t>Human oversight</a:t>
             </a:r>
           </a:p>
         </p:txBody>
@@ -9360,7 +9360,7 @@
                 </a:solidFill>
                 <a:latin typeface="Arial"/>
               </a:rPr>
-              <a:t>Offline AI-only 24-case answer comparison:</a:t>
+              <a:t>Unanswered questions offer human review. After</a:t>
             </a:r>
           </a:p>
           <a:p>
@@ -9379,7 +9379,7 @@
                 </a:solidFill>
                 <a:latin typeface="Arial"/>
               </a:rPr>
-              <a:t>full context 17/24 complete vs keyword 13/24;</a:t>
+              <a:t>confirmation, the same chat and verified context are</a:t>
             </a:r>
           </a:p>
           <a:p>
@@ -9398,7 +9398,7 @@
                 </a:solidFill>
                 <a:latin typeface="Arial"/>
               </a:rPr>
-              <a:t>2/24 forbidden claims in full. Human review pending.</a:t>
+              <a:t>stored with a roster assignee; the bot pauses.</a:t>
             </a:r>
           </a:p>
         </p:txBody>
@@ -9487,7 +9487,7 @@
                 </a:solidFill>
                 <a:latin typeface="Arial"/>
               </a:rPr>
-              <a:t>Learned retrieval diagnostic: E5 recall@5 84.3% vs keyword 38.9% on 18 cases. E5 is not deployed.</a:t>
+              <a:t>Prototype boundary: the roster does not show live availability, and no employee reply or bank decision is connected.</a:t>
             </a:r>
           </a:p>
         </p:txBody>

</xml_diff>

<commit_message>
Focus operations slide on safeguards and human oversight (#9)
</commit_message>
<xml_diff>
--- a/presentation/atlas_factored_hackathon_2026.pptx
+++ b/presentation/atlas_factored_hackathon_2026.pptx
@@ -8332,7 +8332,7 @@
                 </a:solidFill>
                 <a:latin typeface="Arial"/>
               </a:rPr>
-              <a:t>Built with limits, checks, and a safe fallback</a:t>
+              <a:t>Built with controlled actions and a safe fallback</a:t>
             </a:r>
           </a:p>
         </p:txBody>
@@ -8374,7 +8374,7 @@
                 </a:solidFill>
                 <a:latin typeface="Arial"/>
               </a:rPr>
-              <a:t>The demo is deployed; the measured evidence is deliberately narrower than a production claim.</a:t>
+              <a:t>The deployed demo keeps customer data, model answers, and verified actions within distinct boundaries.</a:t>
             </a:r>
           </a:p>
         </p:txBody>
@@ -9062,7 +9062,7 @@
                 </a:solidFill>
                 <a:latin typeface="Arial"/>
               </a:rPr>
-              <a:t>Scalability + cost</a:t>
+              <a:t>Scalability</a:t>
             </a:r>
           </a:p>
         </p:txBody>
@@ -9104,7 +9104,7 @@
                 </a:solidFill>
                 <a:latin typeface="Arial"/>
               </a:rPr>
-              <a:t>Lambda + on-demand DynamoDB; shared 200 model</a:t>
+              <a:t>Lambda + on-demand DynamoDB keep compute and state</a:t>
             </a:r>
           </a:p>
           <a:p>
@@ -9123,7 +9123,7 @@
                 </a:solidFill>
                 <a:latin typeface="Arial"/>
               </a:rPr>
-              <a:t>attempts/day. Six-visitor check: 24/24 requests.</a:t>
+              <a:t>separate. Shared sessions support concurrent requests.</a:t>
             </a:r>
           </a:p>
           <a:p>
@@ -9142,7 +9142,7 @@
                 </a:solidFill>
                 <a:latin typeface="Arial"/>
               </a:rPr>
-              <a:t>Regional Lambda concurrency quota: 10; no peak test.</a:t>
+              <a:t>Six-visitor check: 24/24 requests; no peak load test.</a:t>
             </a:r>
           </a:p>
         </p:txBody>
@@ -9318,7 +9318,7 @@
                 </a:solidFill>
                 <a:latin typeface="Arial"/>
               </a:rPr>
-              <a:t>Quality + baseline</a:t>
+              <a:t>Human oversight</a:t>
             </a:r>
           </a:p>
         </p:txBody>
@@ -9360,7 +9360,7 @@
                 </a:solidFill>
                 <a:latin typeface="Arial"/>
               </a:rPr>
-              <a:t>Offline AI-only 24-case answer comparison:</a:t>
+              <a:t>Unanswered questions offer human review. After</a:t>
             </a:r>
           </a:p>
           <a:p>
@@ -9379,7 +9379,7 @@
                 </a:solidFill>
                 <a:latin typeface="Arial"/>
               </a:rPr>
-              <a:t>full context 17/24 complete vs keyword 13/24;</a:t>
+              <a:t>confirmation, the same chat and verified context are</a:t>
             </a:r>
           </a:p>
           <a:p>
@@ -9398,7 +9398,7 @@
                 </a:solidFill>
                 <a:latin typeface="Arial"/>
               </a:rPr>
-              <a:t>2/24 forbidden claims in full. Human review pending.</a:t>
+              <a:t>stored with a roster assignee; the bot pauses.</a:t>
             </a:r>
           </a:p>
         </p:txBody>
@@ -9487,7 +9487,7 @@
                 </a:solidFill>
                 <a:latin typeface="Arial"/>
               </a:rPr>
-              <a:t>Learned retrieval diagnostic: E5 recall@5 84.3% vs keyword 38.9% on 18 cases. E5 is not deployed.</a:t>
+              <a:t>Prototype boundary: the roster does not show live availability, and no employee reply or bank decision is connected.</a:t>
             </a:r>
           </a:p>
         </p:txBody>

</xml_diff>

<commit_message>
Document live conversation checks and refresh pitch deck
</commit_message>
<xml_diff>
--- a/presentation/atlas_factored_hackathon_2026.pptx
+++ b/presentation/atlas_factored_hackathon_2026.pptx
@@ -6592,7 +6592,7 @@
                 </a:solidFill>
                 <a:latin typeface="Arial"/>
               </a:rPr>
-              <a:t>The model answers; the service controls actions</a:t>
+              <a:t>Claude routes and answers; the service controls actions</a:t>
             </a:r>
           </a:p>
         </p:txBody>
@@ -6634,7 +6634,7 @@
                 </a:solidFill>
                 <a:latin typeface="Arial"/>
               </a:rPr>
-              <a:t>A server-owned state machine separates conversation from policy, permissions, and durable outcomes.</a:t>
+              <a:t>A bounded intent choice comes before service-owned policy, consent, and durable outcomes.</a:t>
             </a:r>
           </a:p>
         </p:txBody>
@@ -7065,7 +7065,7 @@
                 </a:solidFill>
                 <a:latin typeface="Arial"/>
               </a:rPr>
-              <a:t>Active card + intent</a:t>
+              <a:t>Haiku: bounded intent</a:t>
             </a:r>
           </a:p>
           <a:p>
@@ -7084,7 +7084,7 @@
                 </a:solidFill>
                 <a:latin typeface="Arial"/>
               </a:rPr>
-              <a:t>Consent + confirmation</a:t>
+              <a:t>Service validates session</a:t>
             </a:r>
           </a:p>
         </p:txBody>
@@ -7489,7 +7489,7 @@
                 </a:solidFill>
                 <a:latin typeface="Arial"/>
               </a:rPr>
-              <a:t>Versioned facts → Claude when needed</a:t>
+              <a:t>Sonnet + versioned public facts</a:t>
             </a:r>
           </a:p>
           <a:p>
@@ -8290,7 +8290,7 @@
                 </a:solidFill>
                 <a:latin typeface="Arial"/>
               </a:rPr>
-              <a:t>04  /  OPERATING DISCIPLINE</a:t>
+              <a:t>04  /  MEASURED BEHAVIOR</a:t>
             </a:r>
           </a:p>
         </p:txBody>
@@ -8332,7 +8332,7 @@
                 </a:solidFill>
                 <a:latin typeface="Arial"/>
               </a:rPr>
-              <a:t>Built with controlled actions and a safe fallback</a:t>
+              <a:t>Live checks show progress and a remaining failure</a:t>
             </a:r>
           </a:p>
         </p:txBody>
@@ -8374,7 +8374,7 @@
                 </a:solidFill>
                 <a:latin typeface="Arial"/>
               </a:rPr>
-              <a:t>The deployed demo keeps customer data, model answers, and verified actions within distinct boundaries.</a:t>
+              <a:t>4 October production smoke probes are separate from the earlier paired evaluation and judge rehearsal.</a:t>
             </a:r>
           </a:p>
         </p:txBody>
@@ -8550,7 +8550,7 @@
                 </a:solidFill>
                 <a:latin typeface="Arial"/>
               </a:rPr>
-              <a:t>Security + privacy</a:t>
+              <a:t>Product facts + context</a:t>
             </a:r>
           </a:p>
         </p:txBody>
@@ -8592,7 +8592,7 @@
                 </a:solidFill>
                 <a:latin typeface="Arial"/>
               </a:rPr>
-              <a:t>Public app has fictional fixtures; server-bound sessions.</a:t>
+              <a:t>Benefits and monthly fee answered together with facts.</a:t>
             </a:r>
           </a:p>
           <a:p>
@@ -8611,7 +8611,7 @@
                 </a:solidFill>
                 <a:latin typeface="Arial"/>
               </a:rPr>
-              <a:t>Reviewer code is separate. Secrets stay in SSM; no raw</a:t>
+              <a:t>'This card' kept Horizon. A two-card cheaper question</a:t>
             </a:r>
           </a:p>
           <a:p>
@@ -8630,7 +8630,7 @@
                 </a:solidFill>
                 <a:latin typeface="Arial"/>
               </a:rPr>
-              <a:t>organizer customer rows are sent to Claude.</a:t>
+              <a:t>failed to clarify its price reference.</a:t>
             </a:r>
           </a:p>
         </p:txBody>
@@ -8806,7 +8806,7 @@
                 </a:solidFill>
                 <a:latin typeface="Arial"/>
               </a:rPr>
-              <a:t>Reliability + audit</a:t>
+              <a:t>Intent + consent</a:t>
             </a:r>
           </a:p>
         </p:txBody>
@@ -8848,7 +8848,7 @@
                 </a:solidFill>
                 <a:latin typeface="Arial"/>
               </a:rPr>
-              <a:t>12/12 journey checks; 3/3 mock application read-backs.</a:t>
+              <a:t>Negation then application reached card-specific consent.</a:t>
             </a:r>
           </a:p>
           <a:p>
@@ -8867,7 +8867,7 @@
                 </a:solidFill>
                 <a:latin typeface="Arial"/>
               </a:rPr>
-              <a:t>Idempotent writes and safe model fallback. CloudWatch</a:t>
+              <a:t>An unnamed other card triggered card choice. Declined</a:t>
             </a:r>
           </a:p>
           <a:p>
@@ -8886,7 +8886,7 @@
                 </a:solidFill>
                 <a:latin typeface="Arial"/>
               </a:rPr>
-              <a:t>records sanitized route/status metrics and alarms.</a:t>
+              <a:t>precheck never created an application by itself.</a:t>
             </a:r>
           </a:p>
         </p:txBody>
@@ -9062,7 +9062,7 @@
                 </a:solidFill>
                 <a:latin typeface="Arial"/>
               </a:rPr>
-              <a:t>Scalability</a:t>
+              <a:t>Profile + service boundaries</a:t>
             </a:r>
           </a:p>
         </p:txBody>
@@ -9104,7 +9104,7 @@
                 </a:solidFill>
                 <a:latin typeface="Arial"/>
               </a:rPr>
-              <a:t>Lambda + on-demand DynamoDB keep compute and state</a:t>
+              <a:t>Student suggestion named fixture and unverified status.</a:t>
             </a:r>
           </a:p>
           <a:p>
@@ -9123,7 +9123,7 @@
                 </a:solidFill>
                 <a:latin typeface="Arial"/>
               </a:rPr>
-              <a:t>separate. Shared sessions support concurrent requests.</a:t>
+              <a:t>Existing-card cancellation was refused. A second</a:t>
             </a:r>
           </a:p>
           <a:p>
@@ -9142,7 +9142,7 @@
                 </a:solidFill>
                 <a:latin typeface="Arial"/>
               </a:rPr>
-              <a:t>Six-visitor check: 24/24 requests; no peak load test.</a:t>
+              <a:t>application was blocked before another precheck.</a:t>
             </a:r>
           </a:p>
         </p:txBody>
@@ -9318,7 +9318,7 @@
                 </a:solidFill>
                 <a:latin typeface="Arial"/>
               </a:rPr>
-              <a:t>Human oversight</a:t>
+              <a:t>Evidence + capacity</a:t>
             </a:r>
           </a:p>
         </p:txBody>
@@ -9360,7 +9360,7 @@
                 </a:solidFill>
                 <a:latin typeface="Arial"/>
               </a:rPr>
-              <a:t>Unanswered questions offer human review. After</a:t>
+              <a:t>7/8 live smoke scenarios met expectation; 87 local tests</a:t>
             </a:r>
           </a:p>
           <a:p>
@@ -9379,7 +9379,7 @@
                 </a:solidFill>
                 <a:latin typeface="Arial"/>
               </a:rPr>
-              <a:t>confirmation, the same chat and verified context are</a:t>
+              <a:t>passed. Shared cap: 400 model attempts per UTC day.</a:t>
             </a:r>
           </a:p>
           <a:p>
@@ -9398,7 +9398,7 @@
                 </a:solidFill>
                 <a:latin typeface="Arial"/>
               </a:rPr>
-              <a:t>stored with a roster assignee; the bot pauses.</a:t>
+              <a:t>No independent bilingual quality result yet.</a:t>
             </a:r>
           </a:p>
         </p:txBody>
@@ -9487,7 +9487,7 @@
                 </a:solidFill>
                 <a:latin typeface="Arial"/>
               </a:rPr>
-              <a:t>Prototype boundary: the roster does not show live availability, and no employee reply or bank decision is connected.</a:t>
+              <a:t>Separate earlier rehearsal: 12/12 entry paths, 3/3 stored applications, 24/24 requests from six visitors; no peak load test.</a:t>
             </a:r>
           </a:p>
         </p:txBody>

</xml_diff>

<commit_message>
Document live conversation checks and refresh pitch deck (#31)
</commit_message>
<xml_diff>
--- a/presentation/atlas_factored_hackathon_2026.pptx
+++ b/presentation/atlas_factored_hackathon_2026.pptx
@@ -6592,7 +6592,7 @@
                 </a:solidFill>
                 <a:latin typeface="Arial"/>
               </a:rPr>
-              <a:t>The model answers; the service controls actions</a:t>
+              <a:t>Claude routes and answers; the service controls actions</a:t>
             </a:r>
           </a:p>
         </p:txBody>
@@ -6634,7 +6634,7 @@
                 </a:solidFill>
                 <a:latin typeface="Arial"/>
               </a:rPr>
-              <a:t>A server-owned state machine separates conversation from policy, permissions, and durable outcomes.</a:t>
+              <a:t>A bounded intent choice comes before service-owned policy, consent, and durable outcomes.</a:t>
             </a:r>
           </a:p>
         </p:txBody>
@@ -7065,7 +7065,7 @@
                 </a:solidFill>
                 <a:latin typeface="Arial"/>
               </a:rPr>
-              <a:t>Active card + intent</a:t>
+              <a:t>Haiku: bounded intent</a:t>
             </a:r>
           </a:p>
           <a:p>
@@ -7084,7 +7084,7 @@
                 </a:solidFill>
                 <a:latin typeface="Arial"/>
               </a:rPr>
-              <a:t>Consent + confirmation</a:t>
+              <a:t>Service validates session</a:t>
             </a:r>
           </a:p>
         </p:txBody>
@@ -7489,7 +7489,7 @@
                 </a:solidFill>
                 <a:latin typeface="Arial"/>
               </a:rPr>
-              <a:t>Versioned facts → Claude when needed</a:t>
+              <a:t>Sonnet + versioned public facts</a:t>
             </a:r>
           </a:p>
           <a:p>
@@ -8290,7 +8290,7 @@
                 </a:solidFill>
                 <a:latin typeface="Arial"/>
               </a:rPr>
-              <a:t>04  /  OPERATING DISCIPLINE</a:t>
+              <a:t>04  /  MEASURED BEHAVIOR</a:t>
             </a:r>
           </a:p>
         </p:txBody>
@@ -8332,7 +8332,7 @@
                 </a:solidFill>
                 <a:latin typeface="Arial"/>
               </a:rPr>
-              <a:t>Built with controlled actions and a safe fallback</a:t>
+              <a:t>Live checks show progress and a remaining failure</a:t>
             </a:r>
           </a:p>
         </p:txBody>
@@ -8374,7 +8374,7 @@
                 </a:solidFill>
                 <a:latin typeface="Arial"/>
               </a:rPr>
-              <a:t>The deployed demo keeps customer data, model answers, and verified actions within distinct boundaries.</a:t>
+              <a:t>4 October production smoke probes are separate from the earlier paired evaluation and judge rehearsal.</a:t>
             </a:r>
           </a:p>
         </p:txBody>
@@ -8550,7 +8550,7 @@
                 </a:solidFill>
                 <a:latin typeface="Arial"/>
               </a:rPr>
-              <a:t>Security + privacy</a:t>
+              <a:t>Product facts + context</a:t>
             </a:r>
           </a:p>
         </p:txBody>
@@ -8592,7 +8592,7 @@
                 </a:solidFill>
                 <a:latin typeface="Arial"/>
               </a:rPr>
-              <a:t>Public app has fictional fixtures; server-bound sessions.</a:t>
+              <a:t>Benefits and monthly fee answered together with facts.</a:t>
             </a:r>
           </a:p>
           <a:p>
@@ -8611,7 +8611,7 @@
                 </a:solidFill>
                 <a:latin typeface="Arial"/>
               </a:rPr>
-              <a:t>Reviewer code is separate. Secrets stay in SSM; no raw</a:t>
+              <a:t>'This card' kept Horizon. A two-card cheaper question</a:t>
             </a:r>
           </a:p>
           <a:p>
@@ -8630,7 +8630,7 @@
                 </a:solidFill>
                 <a:latin typeface="Arial"/>
               </a:rPr>
-              <a:t>organizer customer rows are sent to Claude.</a:t>
+              <a:t>failed to clarify its price reference.</a:t>
             </a:r>
           </a:p>
         </p:txBody>
@@ -8806,7 +8806,7 @@
                 </a:solidFill>
                 <a:latin typeface="Arial"/>
               </a:rPr>
-              <a:t>Reliability + audit</a:t>
+              <a:t>Intent + consent</a:t>
             </a:r>
           </a:p>
         </p:txBody>
@@ -8848,7 +8848,7 @@
                 </a:solidFill>
                 <a:latin typeface="Arial"/>
               </a:rPr>
-              <a:t>12/12 journey checks; 3/3 mock application read-backs.</a:t>
+              <a:t>Negation then application reached card-specific consent.</a:t>
             </a:r>
           </a:p>
           <a:p>
@@ -8867,7 +8867,7 @@
                 </a:solidFill>
                 <a:latin typeface="Arial"/>
               </a:rPr>
-              <a:t>Idempotent writes and safe model fallback. CloudWatch</a:t>
+              <a:t>An unnamed other card triggered card choice. Declined</a:t>
             </a:r>
           </a:p>
           <a:p>
@@ -8886,7 +8886,7 @@
                 </a:solidFill>
                 <a:latin typeface="Arial"/>
               </a:rPr>
-              <a:t>records sanitized route/status metrics and alarms.</a:t>
+              <a:t>precheck never created an application by itself.</a:t>
             </a:r>
           </a:p>
         </p:txBody>
@@ -9062,7 +9062,7 @@
                 </a:solidFill>
                 <a:latin typeface="Arial"/>
               </a:rPr>
-              <a:t>Scalability</a:t>
+              <a:t>Profile + service boundaries</a:t>
             </a:r>
           </a:p>
         </p:txBody>
@@ -9104,7 +9104,7 @@
                 </a:solidFill>
                 <a:latin typeface="Arial"/>
               </a:rPr>
-              <a:t>Lambda + on-demand DynamoDB keep compute and state</a:t>
+              <a:t>Student suggestion named fixture and unverified status.</a:t>
             </a:r>
           </a:p>
           <a:p>
@@ -9123,7 +9123,7 @@
                 </a:solidFill>
                 <a:latin typeface="Arial"/>
               </a:rPr>
-              <a:t>separate. Shared sessions support concurrent requests.</a:t>
+              <a:t>Existing-card cancellation was refused. A second</a:t>
             </a:r>
           </a:p>
           <a:p>
@@ -9142,7 +9142,7 @@
                 </a:solidFill>
                 <a:latin typeface="Arial"/>
               </a:rPr>
-              <a:t>Six-visitor check: 24/24 requests; no peak load test.</a:t>
+              <a:t>application was blocked before another precheck.</a:t>
             </a:r>
           </a:p>
         </p:txBody>
@@ -9318,7 +9318,7 @@
                 </a:solidFill>
                 <a:latin typeface="Arial"/>
               </a:rPr>
-              <a:t>Human oversight</a:t>
+              <a:t>Evidence + capacity</a:t>
             </a:r>
           </a:p>
         </p:txBody>
@@ -9360,7 +9360,7 @@
                 </a:solidFill>
                 <a:latin typeface="Arial"/>
               </a:rPr>
-              <a:t>Unanswered questions offer human review. After</a:t>
+              <a:t>7/8 live smoke scenarios met expectation; 87 local tests</a:t>
             </a:r>
           </a:p>
           <a:p>
@@ -9379,7 +9379,7 @@
                 </a:solidFill>
                 <a:latin typeface="Arial"/>
               </a:rPr>
-              <a:t>confirmation, the same chat and verified context are</a:t>
+              <a:t>passed. Shared cap: 400 model attempts per UTC day.</a:t>
             </a:r>
           </a:p>
           <a:p>
@@ -9398,7 +9398,7 @@
                 </a:solidFill>
                 <a:latin typeface="Arial"/>
               </a:rPr>
-              <a:t>stored with a roster assignee; the bot pauses.</a:t>
+              <a:t>No independent bilingual quality result yet.</a:t>
             </a:r>
           </a:p>
         </p:txBody>
@@ -9487,7 +9487,7 @@
                 </a:solidFill>
                 <a:latin typeface="Arial"/>
               </a:rPr>
-              <a:t>Prototype boundary: the roster does not show live availability, and no employee reply or bank decision is connected.</a:t>
+              <a:t>Separate earlier rehearsal: 12/12 entry paths, 3/3 stored applications, 24/24 requests from six visitors; no peak load test.</a:t>
             </a:r>
           </a:p>
         </p:txBody>

</xml_diff>

<commit_message>
Clarify dated rehearsal denominators in deck and docs
</commit_message>
<xml_diff>
--- a/presentation/atlas_factored_hackathon_2026.pptx
+++ b/presentation/atlas_factored_hackathon_2026.pptx
@@ -9481,13 +9481,13 @@
               </a:spcAft>
             </a:pPr>
             <a:r>
-              <a:rPr sz="1030" b="1">
+              <a:rPr sz="960" b="1">
                 <a:solidFill>
                   <a:srgbClr val="176F70"/>
                 </a:solidFill>
                 <a:latin typeface="Arial"/>
               </a:rPr>
-              <a:t>Separate earlier rehearsal: 12/12 entry paths, 3/3 stored applications, 24/24 requests from six visitors; no peak load test.</a:t>
+              <a:t>Earlier 2 Oct rehearsal only: 12 entry/country/language paths; 3 application read-backs; 24 HTTP requests from six visitors.</a:t>
             </a:r>
           </a:p>
         </p:txBody>

</xml_diff>

<commit_message>
Clarify dated rehearsal denominators in deck and docs (#32)
</commit_message>
<xml_diff>
--- a/presentation/atlas_factored_hackathon_2026.pptx
+++ b/presentation/atlas_factored_hackathon_2026.pptx
@@ -9481,13 +9481,13 @@
               </a:spcAft>
             </a:pPr>
             <a:r>
-              <a:rPr sz="1030" b="1">
+              <a:rPr sz="960" b="1">
                 <a:solidFill>
                   <a:srgbClr val="176F70"/>
                 </a:solidFill>
                 <a:latin typeface="Arial"/>
               </a:rPr>
-              <a:t>Separate earlier rehearsal: 12/12 entry paths, 3/3 stored applications, 24/24 requests from six visitors; no peak load test.</a:t>
+              <a:t>Earlier 2 Oct rehearsal only: 12 entry/country/language paths; 3 application read-backs; 24 HTTP requests from six visitors.</a:t>
             </a:r>
           </a:p>
         </p:txBody>

</xml_diff>

<commit_message>
Put current test results in PDF and clarify architecture
</commit_message>
<xml_diff>
--- a/presentation/atlas_factored_hackathon_2026.pptx
+++ b/presentation/atlas_factored_hackathon_2026.pptx
@@ -8332,7 +8332,7 @@
                 </a:solidFill>
                 <a:latin typeface="Arial"/>
               </a:rPr>
-              <a:t>Live checks show progress and a remaining failure</a:t>
+              <a:t>87 automated tests passed; 7 of 8 live flows met expectations</a:t>
             </a:r>
           </a:p>
         </p:txBody>
@@ -8374,7 +8374,7 @@
                 </a:solidFill>
                 <a:latin typeface="Arial"/>
               </a:rPr>
-              <a:t>4 October production smoke probes are separate from the earlier paired evaluation and judge rehearsal.</a:t>
+              <a:t>Current 4 October build · The two-card cheaper comparison remains an open failure.</a:t>
             </a:r>
           </a:p>
         </p:txBody>
@@ -9318,7 +9318,7 @@
                 </a:solidFill>
                 <a:latin typeface="Arial"/>
               </a:rPr>
-              <a:t>Evidence + capacity</a:t>
+              <a:t>Dated evidence + capacity</a:t>
             </a:r>
           </a:p>
         </p:txBody>
@@ -9360,7 +9360,7 @@
                 </a:solidFill>
                 <a:latin typeface="Arial"/>
               </a:rPr>
-              <a:t>7/8 live smoke scenarios met expectation; 87 local tests</a:t>
+              <a:t>Current build: 87 local tests; 7/8 live smoke flows.</a:t>
             </a:r>
           </a:p>
           <a:p>
@@ -9379,7 +9379,7 @@
                 </a:solidFill>
                 <a:latin typeface="Arial"/>
               </a:rPr>
-              <a:t>passed. Shared cap: 400 model attempts per UTC day.</a:t>
+              <a:t>Earlier rehearsal: 12 entry paths, 3 application</a:t>
             </a:r>
           </a:p>
           <a:p>
@@ -9398,7 +9398,7 @@
                 </a:solidFill>
                 <a:latin typeface="Arial"/>
               </a:rPr>
-              <a:t>No independent bilingual quality result yet.</a:t>
+              <a:t>read-backs, 24 HTTP requests from six visitors.</a:t>
             </a:r>
           </a:p>
         </p:txBody>
@@ -9481,13 +9481,13 @@
               </a:spcAft>
             </a:pPr>
             <a:r>
-              <a:rPr sz="960" b="1">
+              <a:rPr sz="1000" b="1">
                 <a:solidFill>
                   <a:srgbClr val="176F70"/>
                 </a:solidFill>
                 <a:latin typeface="Arial"/>
               </a:rPr>
-              <a:t>Earlier 2 Oct rehearsal only: 12 entry/country/language paths; 3 application read-backs; 24 HTTP requests from six visitors.</a:t>
+              <a:t>Separate, noncumulative checks  ·  400 model attempts/day cap  ·  No independent bilingual review or peak load test</a:t>
             </a:r>
           </a:p>
         </p:txBody>

</xml_diff>

<commit_message>
Put current test results in PDF and clarify architecture (#33)
</commit_message>
<xml_diff>
--- a/presentation/atlas_factored_hackathon_2026.pptx
+++ b/presentation/atlas_factored_hackathon_2026.pptx
@@ -8332,7 +8332,7 @@
                 </a:solidFill>
                 <a:latin typeface="Arial"/>
               </a:rPr>
-              <a:t>Live checks show progress and a remaining failure</a:t>
+              <a:t>87 automated tests passed; 7 of 8 live flows met expectations</a:t>
             </a:r>
           </a:p>
         </p:txBody>
@@ -8374,7 +8374,7 @@
                 </a:solidFill>
                 <a:latin typeface="Arial"/>
               </a:rPr>
-              <a:t>4 October production smoke probes are separate from the earlier paired evaluation and judge rehearsal.</a:t>
+              <a:t>Current 4 October build · The two-card cheaper comparison remains an open failure.</a:t>
             </a:r>
           </a:p>
         </p:txBody>
@@ -9318,7 +9318,7 @@
                 </a:solidFill>
                 <a:latin typeface="Arial"/>
               </a:rPr>
-              <a:t>Evidence + capacity</a:t>
+              <a:t>Dated evidence + capacity</a:t>
             </a:r>
           </a:p>
         </p:txBody>
@@ -9360,7 +9360,7 @@
                 </a:solidFill>
                 <a:latin typeface="Arial"/>
               </a:rPr>
-              <a:t>7/8 live smoke scenarios met expectation; 87 local tests</a:t>
+              <a:t>Current build: 87 local tests; 7/8 live smoke flows.</a:t>
             </a:r>
           </a:p>
           <a:p>
@@ -9379,7 +9379,7 @@
                 </a:solidFill>
                 <a:latin typeface="Arial"/>
               </a:rPr>
-              <a:t>passed. Shared cap: 400 model attempts per UTC day.</a:t>
+              <a:t>Earlier rehearsal: 12 entry paths, 3 application</a:t>
             </a:r>
           </a:p>
           <a:p>
@@ -9398,7 +9398,7 @@
                 </a:solidFill>
                 <a:latin typeface="Arial"/>
               </a:rPr>
-              <a:t>No independent bilingual quality result yet.</a:t>
+              <a:t>read-backs, 24 HTTP requests from six visitors.</a:t>
             </a:r>
           </a:p>
         </p:txBody>
@@ -9481,13 +9481,13 @@
               </a:spcAft>
             </a:pPr>
             <a:r>
-              <a:rPr sz="960" b="1">
+              <a:rPr sz="1000" b="1">
                 <a:solidFill>
                   <a:srgbClr val="176F70"/>
                 </a:solidFill>
                 <a:latin typeface="Arial"/>
               </a:rPr>
-              <a:t>Earlier 2 Oct rehearsal only: 12 entry/country/language paths; 3 application read-backs; 24 HTTP requests from six visitors.</a:t>
+              <a:t>Separate, noncumulative checks  ·  400 model attempts/day cap  ·  No independent bilingual review or peak load test</a:t>
             </a:r>
           </a:p>
         </p:txBody>

</xml_diff>

<commit_message>
Explain failed cheaper-card flow in slide footnote
</commit_message>
<xml_diff>
--- a/presentation/atlas_factored_hackathon_2026.pptx
+++ b/presentation/atlas_factored_hackathon_2026.pptx
@@ -8332,7 +8332,7 @@
                 </a:solidFill>
                 <a:latin typeface="Arial"/>
               </a:rPr>
-              <a:t>87 automated tests passed; 7 of 8 live flows met expectations</a:t>
+              <a:t>87 automated tests passed; 7/8 live flows met expectations*</a:t>
             </a:r>
           </a:p>
         </p:txBody>
@@ -9360,7 +9360,7 @@
                 </a:solidFill>
                 <a:latin typeface="Arial"/>
               </a:rPr>
-              <a:t>Current build: 87 local tests; 7/8 live smoke flows.</a:t>
+              <a:t>Current build: 87 local tests; 7/8* live smoke flows.</a:t>
             </a:r>
           </a:p>
           <a:p>
@@ -9411,8 +9411,8 @@
         </p:nvSpPr>
         <p:spPr>
           <a:xfrm>
-            <a:off x="512064" y="5650992"/>
-            <a:ext cx="11173968" cy="502920"/>
+            <a:off x="512064" y="5513832"/>
+            <a:ext cx="11173968" cy="740664"/>
           </a:xfrm>
           <a:prstGeom prst="roundRect">
             <a:avLst>
@@ -9458,8 +9458,8 @@
         </p:nvSpPr>
         <p:spPr>
           <a:xfrm>
-            <a:off x="713232" y="5806440"/>
-            <a:ext cx="10744200" cy="219456"/>
+            <a:off x="713232" y="5605272"/>
+            <a:ext cx="10744200" cy="164592"/>
           </a:xfrm>
           <a:prstGeom prst="rect">
             <a:avLst/>
@@ -9481,7 +9481,91 @@
               </a:spcAft>
             </a:pPr>
             <a:r>
-              <a:rPr sz="1000" b="1">
+              <a:rPr sz="919" b="1">
+                <a:solidFill>
+                  <a:srgbClr val="112B38"/>
+                </a:solidFill>
+                <a:latin typeface="Arial"/>
+              </a:rPr>
+              <a:t>* After Rewards and Summit, 'a cheaper one' (PT: 'um mais barato') did not trigger a question about the reference card.</a:t>
+            </a:r>
+          </a:p>
+        </p:txBody>
+      </p:sp>
+      <p:sp>
+        <p:nvSpPr>
+          <p:cNvPr id="34" name="TextBox 33"/>
+          <p:cNvSpPr txBox="1"/>
+          <p:nvPr/>
+        </p:nvSpPr>
+        <p:spPr>
+          <a:xfrm>
+            <a:off x="713232" y="5815584"/>
+            <a:ext cx="10744200" cy="164592"/>
+          </a:xfrm>
+          <a:prstGeom prst="rect">
+            <a:avLst/>
+          </a:prstGeom>
+          <a:noFill/>
+        </p:spPr>
+        <p:txBody>
+          <a:bodyPr wrap="square" lIns="0" rIns="0" tIns="0" bIns="0" anchor="t">
+            <a:spAutoFit/>
+          </a:bodyPr>
+          <a:lstStyle/>
+          <a:p>
+            <a:pPr algn="l">
+              <a:lnSpc>
+                <a:spcPct val="100000"/>
+              </a:lnSpc>
+              <a:spcAft>
+                <a:spcPts val="0"/>
+              </a:spcAft>
+            </a:pPr>
+            <a:r>
+              <a:rPr sz="919" b="0">
+                <a:solidFill>
+                  <a:srgbClr val="112B38"/>
+                </a:solidFill>
+                <a:latin typeface="Arial"/>
+              </a:rPr>
+              <a:t>It listed alternatives; a separate 'cheaper than Rewards' answer even included the more expensive Summit.</a:t>
+            </a:r>
+          </a:p>
+        </p:txBody>
+      </p:sp>
+      <p:sp>
+        <p:nvSpPr>
+          <p:cNvPr id="35" name="TextBox 34"/>
+          <p:cNvSpPr txBox="1"/>
+          <p:nvPr/>
+        </p:nvSpPr>
+        <p:spPr>
+          <a:xfrm>
+            <a:off x="713232" y="6053328"/>
+            <a:ext cx="10744200" cy="128016"/>
+          </a:xfrm>
+          <a:prstGeom prst="rect">
+            <a:avLst/>
+          </a:prstGeom>
+          <a:noFill/>
+        </p:spPr>
+        <p:txBody>
+          <a:bodyPr wrap="square" lIns="0" rIns="0" tIns="0" bIns="0" anchor="t">
+            <a:spAutoFit/>
+          </a:bodyPr>
+          <a:lstStyle/>
+          <a:p>
+            <a:pPr algn="l">
+              <a:lnSpc>
+                <a:spcPct val="100000"/>
+              </a:lnSpc>
+              <a:spcAft>
+                <a:spcPts val="0"/>
+              </a:spcAft>
+            </a:pPr>
+            <a:r>
+              <a:rPr sz="819" b="1">
                 <a:solidFill>
                   <a:srgbClr val="176F70"/>
                 </a:solidFill>

</xml_diff>

<commit_message>
Explain failed cheaper-card flow in slide footnote (#35)
</commit_message>
<xml_diff>
--- a/presentation/atlas_factored_hackathon_2026.pptx
+++ b/presentation/atlas_factored_hackathon_2026.pptx
@@ -8332,7 +8332,7 @@
                 </a:solidFill>
                 <a:latin typeface="Arial"/>
               </a:rPr>
-              <a:t>87 automated tests passed; 7 of 8 live flows met expectations</a:t>
+              <a:t>87 automated tests passed; 7/8 live flows met expectations*</a:t>
             </a:r>
           </a:p>
         </p:txBody>
@@ -9360,7 +9360,7 @@
                 </a:solidFill>
                 <a:latin typeface="Arial"/>
               </a:rPr>
-              <a:t>Current build: 87 local tests; 7/8 live smoke flows.</a:t>
+              <a:t>Current build: 87 local tests; 7/8* live smoke flows.</a:t>
             </a:r>
           </a:p>
           <a:p>
@@ -9411,8 +9411,8 @@
         </p:nvSpPr>
         <p:spPr>
           <a:xfrm>
-            <a:off x="512064" y="5650992"/>
-            <a:ext cx="11173968" cy="502920"/>
+            <a:off x="512064" y="5513832"/>
+            <a:ext cx="11173968" cy="740664"/>
           </a:xfrm>
           <a:prstGeom prst="roundRect">
             <a:avLst>
@@ -9458,8 +9458,8 @@
         </p:nvSpPr>
         <p:spPr>
           <a:xfrm>
-            <a:off x="713232" y="5806440"/>
-            <a:ext cx="10744200" cy="219456"/>
+            <a:off x="713232" y="5605272"/>
+            <a:ext cx="10744200" cy="164592"/>
           </a:xfrm>
           <a:prstGeom prst="rect">
             <a:avLst/>
@@ -9481,7 +9481,91 @@
               </a:spcAft>
             </a:pPr>
             <a:r>
-              <a:rPr sz="1000" b="1">
+              <a:rPr sz="919" b="1">
+                <a:solidFill>
+                  <a:srgbClr val="112B38"/>
+                </a:solidFill>
+                <a:latin typeface="Arial"/>
+              </a:rPr>
+              <a:t>* After Rewards and Summit, 'a cheaper one' (PT: 'um mais barato') did not trigger a question about the reference card.</a:t>
+            </a:r>
+          </a:p>
+        </p:txBody>
+      </p:sp>
+      <p:sp>
+        <p:nvSpPr>
+          <p:cNvPr id="34" name="TextBox 33"/>
+          <p:cNvSpPr txBox="1"/>
+          <p:nvPr/>
+        </p:nvSpPr>
+        <p:spPr>
+          <a:xfrm>
+            <a:off x="713232" y="5815584"/>
+            <a:ext cx="10744200" cy="164592"/>
+          </a:xfrm>
+          <a:prstGeom prst="rect">
+            <a:avLst/>
+          </a:prstGeom>
+          <a:noFill/>
+        </p:spPr>
+        <p:txBody>
+          <a:bodyPr wrap="square" lIns="0" rIns="0" tIns="0" bIns="0" anchor="t">
+            <a:spAutoFit/>
+          </a:bodyPr>
+          <a:lstStyle/>
+          <a:p>
+            <a:pPr algn="l">
+              <a:lnSpc>
+                <a:spcPct val="100000"/>
+              </a:lnSpc>
+              <a:spcAft>
+                <a:spcPts val="0"/>
+              </a:spcAft>
+            </a:pPr>
+            <a:r>
+              <a:rPr sz="919" b="0">
+                <a:solidFill>
+                  <a:srgbClr val="112B38"/>
+                </a:solidFill>
+                <a:latin typeface="Arial"/>
+              </a:rPr>
+              <a:t>It listed alternatives; a separate 'cheaper than Rewards' answer even included the more expensive Summit.</a:t>
+            </a:r>
+          </a:p>
+        </p:txBody>
+      </p:sp>
+      <p:sp>
+        <p:nvSpPr>
+          <p:cNvPr id="35" name="TextBox 34"/>
+          <p:cNvSpPr txBox="1"/>
+          <p:nvPr/>
+        </p:nvSpPr>
+        <p:spPr>
+          <a:xfrm>
+            <a:off x="713232" y="6053328"/>
+            <a:ext cx="10744200" cy="128016"/>
+          </a:xfrm>
+          <a:prstGeom prst="rect">
+            <a:avLst/>
+          </a:prstGeom>
+          <a:noFill/>
+        </p:spPr>
+        <p:txBody>
+          <a:bodyPr wrap="square" lIns="0" rIns="0" tIns="0" bIns="0" anchor="t">
+            <a:spAutoFit/>
+          </a:bodyPr>
+          <a:lstStyle/>
+          <a:p>
+            <a:pPr algn="l">
+              <a:lnSpc>
+                <a:spcPct val="100000"/>
+              </a:lnSpc>
+              <a:spcAft>
+                <a:spcPts val="0"/>
+              </a:spcAft>
+            </a:pPr>
+            <a:r>
+              <a:rPr sz="819" b="1">
                 <a:solidFill>
                   <a:srgbClr val="176F70"/>
                 </a:solidFill>

</xml_diff>

<commit_message>
Trim measured-behavior slide caveats
</commit_message>
<xml_diff>
--- a/presentation/atlas_factored_hackathon_2026.pptx
+++ b/presentation/atlas_factored_hackathon_2026.pptx
@@ -8374,7 +8374,7 @@
                 </a:solidFill>
                 <a:latin typeface="Arial"/>
               </a:rPr>
-              <a:t>Current 4 October build · The two-card cheaper comparison remains an open failure.</a:t>
+              <a:t>Current 4 October build · agent-run production smoke checks.</a:t>
             </a:r>
           </a:p>
         </p:txBody>
@@ -9571,7 +9571,7 @@
                 </a:solidFill>
                 <a:latin typeface="Arial"/>
               </a:rPr>
-              <a:t>Separate, noncumulative checks  ·  400 model attempts/day cap  ·  No independent bilingual review or peak load test</a:t>
+              <a:t>Separate, noncumulative checks  ·  400 model attempts/day cap</a:t>
             </a:r>
           </a:p>
         </p:txBody>

</xml_diff>

<commit_message>
Trim measured-behavior slide caveats (#36)
</commit_message>
<xml_diff>
--- a/presentation/atlas_factored_hackathon_2026.pptx
+++ b/presentation/atlas_factored_hackathon_2026.pptx
@@ -8374,7 +8374,7 @@
                 </a:solidFill>
                 <a:latin typeface="Arial"/>
               </a:rPr>
-              <a:t>Current 4 October build · The two-card cheaper comparison remains an open failure.</a:t>
+              <a:t>Current 4 October build · agent-run production smoke checks.</a:t>
             </a:r>
           </a:p>
         </p:txBody>
@@ -9571,7 +9571,7 @@
                 </a:solidFill>
                 <a:latin typeface="Arial"/>
               </a:rPr>
-              <a:t>Separate, noncumulative checks  ·  400 model attempts/day cap  ·  No independent bilingual review or peak load test</a:t>
+              <a:t>Separate, noncumulative checks  ·  400 model attempts/day cap</a:t>
             </a:r>
           </a:p>
         </p:txBody>

</xml_diff>

<commit_message>
Focus measured slide cards on successful flows
</commit_message>
<xml_diff>
--- a/presentation/atlas_factored_hackathon_2026.pptx
+++ b/presentation/atlas_factored_hackathon_2026.pptx
@@ -8592,7 +8592,7 @@
                 </a:solidFill>
                 <a:latin typeface="Arial"/>
               </a:rPr>
-              <a:t>Benefits and monthly fee answered together with facts.</a:t>
+              <a:t>Benefits and monthly fee came together with citations.</a:t>
             </a:r>
           </a:p>
           <a:p>
@@ -8611,7 +8611,7 @@
                 </a:solidFill>
                 <a:latin typeface="Arial"/>
               </a:rPr>
-              <a:t>'This card' kept Horizon. A two-card cheaper question</a:t>
+              <a:t>'This card' kept Horizon across turns. A comparison</a:t>
             </a:r>
           </a:p>
           <a:p>
@@ -8630,7 +8630,7 @@
                 </a:solidFill>
                 <a:latin typeface="Arial"/>
               </a:rPr>
-              <a:t>failed to clarify its price reference.</a:t>
+              <a:t>against Summit returned lower-cost options.</a:t>
             </a:r>
           </a:p>
         </p:txBody>
@@ -8848,7 +8848,7 @@
                 </a:solidFill>
                 <a:latin typeface="Arial"/>
               </a:rPr>
-              <a:t>Negation then application reached card-specific consent.</a:t>
+              <a:t>A new application request reached card-specific consent.</a:t>
             </a:r>
           </a:p>
           <a:p>
@@ -8867,7 +8867,7 @@
                 </a:solidFill>
                 <a:latin typeface="Arial"/>
               </a:rPr>
-              <a:t>An unnamed other card triggered card choice. Declined</a:t>
+              <a:t>An unnamed other card prompted a card choice.</a:t>
             </a:r>
           </a:p>
           <a:p>
@@ -8886,7 +8886,7 @@
                 </a:solidFill>
                 <a:latin typeface="Arial"/>
               </a:rPr>
-              <a:t>precheck never created an application by itself.</a:t>
+              <a:t>Precheck decline led to a separate application choice.</a:t>
             </a:r>
           </a:p>
         </p:txBody>
@@ -9104,7 +9104,7 @@
                 </a:solidFill>
                 <a:latin typeface="Arial"/>
               </a:rPr>
-              <a:t>Student suggestion named fixture and unverified status.</a:t>
+              <a:t>Student suggestion named the selected demo profile and</a:t>
             </a:r>
           </a:p>
           <a:p>
@@ -9123,7 +9123,7 @@
                 </a:solidFill>
                 <a:latin typeface="Arial"/>
               </a:rPr>
-              <a:t>Existing-card cancellation was refused. A second</a:t>
+              <a:t>its unverified enrollment. Cancellation got a support</a:t>
             </a:r>
           </a:p>
           <a:p>
@@ -9142,7 +9142,7 @@
                 </a:solidFill>
                 <a:latin typeface="Arial"/>
               </a:rPr>
-              <a:t>application was blocked before another precheck.</a:t>
+              <a:t>path; a second application got the one-per-chat rule.</a:t>
             </a:r>
           </a:p>
         </p:txBody>

</xml_diff>

<commit_message>
Focus measured slide cards on successful flows (#37)
</commit_message>
<xml_diff>
--- a/presentation/atlas_factored_hackathon_2026.pptx
+++ b/presentation/atlas_factored_hackathon_2026.pptx
@@ -8592,7 +8592,7 @@
                 </a:solidFill>
                 <a:latin typeface="Arial"/>
               </a:rPr>
-              <a:t>Benefits and monthly fee answered together with facts.</a:t>
+              <a:t>Benefits and monthly fee came together with citations.</a:t>
             </a:r>
           </a:p>
           <a:p>
@@ -8611,7 +8611,7 @@
                 </a:solidFill>
                 <a:latin typeface="Arial"/>
               </a:rPr>
-              <a:t>'This card' kept Horizon. A two-card cheaper question</a:t>
+              <a:t>'This card' kept Horizon across turns. A comparison</a:t>
             </a:r>
           </a:p>
           <a:p>
@@ -8630,7 +8630,7 @@
                 </a:solidFill>
                 <a:latin typeface="Arial"/>
               </a:rPr>
-              <a:t>failed to clarify its price reference.</a:t>
+              <a:t>against Summit returned lower-cost options.</a:t>
             </a:r>
           </a:p>
         </p:txBody>
@@ -8848,7 +8848,7 @@
                 </a:solidFill>
                 <a:latin typeface="Arial"/>
               </a:rPr>
-              <a:t>Negation then application reached card-specific consent.</a:t>
+              <a:t>A new application request reached card-specific consent.</a:t>
             </a:r>
           </a:p>
           <a:p>
@@ -8867,7 +8867,7 @@
                 </a:solidFill>
                 <a:latin typeface="Arial"/>
               </a:rPr>
-              <a:t>An unnamed other card triggered card choice. Declined</a:t>
+              <a:t>An unnamed other card prompted a card choice.</a:t>
             </a:r>
           </a:p>
           <a:p>
@@ -8886,7 +8886,7 @@
                 </a:solidFill>
                 <a:latin typeface="Arial"/>
               </a:rPr>
-              <a:t>precheck never created an application by itself.</a:t>
+              <a:t>Precheck decline led to a separate application choice.</a:t>
             </a:r>
           </a:p>
         </p:txBody>
@@ -9104,7 +9104,7 @@
                 </a:solidFill>
                 <a:latin typeface="Arial"/>
               </a:rPr>
-              <a:t>Student suggestion named fixture and unverified status.</a:t>
+              <a:t>Student suggestion named the selected demo profile and</a:t>
             </a:r>
           </a:p>
           <a:p>
@@ -9123,7 +9123,7 @@
                 </a:solidFill>
                 <a:latin typeface="Arial"/>
               </a:rPr>
-              <a:t>Existing-card cancellation was refused. A second</a:t>
+              <a:t>its unverified enrollment. Cancellation got a support</a:t>
             </a:r>
           </a:p>
           <a:p>
@@ -9142,7 +9142,7 @@
                 </a:solidFill>
                 <a:latin typeface="Arial"/>
               </a:rPr>
-              <a:t>application was blocked before another precheck.</a:t>
+              <a:t>path; a second application got the one-per-chat rule.</a:t>
             </a:r>
           </a:p>
         </p:txBody>

</xml_diff>

<commit_message>
Refocus pitch deck on product journey and technical value
</commit_message>
<xml_diff>
--- a/presentation/atlas_factored_hackathon_2026.pptx
+++ b/presentation/atlas_factored_hackathon_2026.pptx
@@ -3479,7 +3479,7 @@
                 </a:solidFill>
                 <a:latin typeface="Arial"/>
               </a:rPr>
-              <a:t>A clearer path from card question</a:t>
+              <a:t>Understand a card. Find a fit.</a:t>
             </a:r>
           </a:p>
           <a:p>
@@ -3498,7 +3498,7 @@
                 </a:solidFill>
                 <a:latin typeface="Arial"/>
               </a:rPr>
-              <a:t>to a verified next step</a:t>
+              <a:t>Take a verified next step.</a:t>
             </a:r>
           </a:p>
         </p:txBody>
@@ -3540,7 +3540,7 @@
                 </a:solidFill>
                 <a:latin typeface="Arial"/>
               </a:rPr>
-              <a:t>Credit-card product information, simulated eligibility,</a:t>
+              <a:t>Bilingual card guidance, simulated eligibility,</a:t>
             </a:r>
           </a:p>
           <a:p>
@@ -3559,7 +3559,7 @@
                 </a:solidFill>
                 <a:latin typeface="Arial"/>
               </a:rPr>
-              <a:t>and human-review handoff in Spanish and Portuguese.</a:t>
+              <a:t>and a path to human review in one conversation.</a:t>
             </a:r>
           </a:p>
         </p:txBody>
@@ -4085,7 +4085,7 @@
                 </a:solidFill>
                 <a:latin typeface="Arial"/>
               </a:rPr>
-              <a:t>01  /  THE CUSTOMER PROBLEM</a:t>
+              <a:t>01  /  THE PRODUCT JOURNEY</a:t>
             </a:r>
           </a:p>
         </p:txBody>
@@ -4127,7 +4127,7 @@
                 </a:solidFill>
                 <a:latin typeface="Arial"/>
               </a:rPr>
-              <a:t>Help a prospective card customer decide with confidence</a:t>
+              <a:t>From a card question to a customer-controlled next step</a:t>
             </a:r>
           </a:p>
         </p:txBody>
@@ -4169,7 +4169,7 @@
                 </a:solidFill>
                 <a:latin typeface="Arial"/>
               </a:rPr>
-              <a:t>A customer can ask natural questions, compare cards, request a simulated precheck, or ask for a person.</a:t>
+              <a:t>Spanish and Portuguese chat helps a visitor understand the offers before choosing whether to act.</a:t>
             </a:r>
           </a:p>
         </p:txBody>
@@ -4183,7 +4183,7 @@
         <p:spPr>
           <a:xfrm>
             <a:off x="512064" y="1938528"/>
-            <a:ext cx="11173968" cy="795528"/>
+            <a:ext cx="11173968" cy="640080"/>
           </a:xfrm>
           <a:prstGeom prst="roundRect">
             <a:avLst>
@@ -4227,8 +4227,8 @@
         </p:nvSpPr>
         <p:spPr>
           <a:xfrm>
-            <a:off x="768096" y="2057400"/>
-            <a:ext cx="10643616" cy="585216"/>
+            <a:off x="768096" y="2121408"/>
+            <a:ext cx="10643616" cy="246888"/>
           </a:xfrm>
           <a:prstGeom prst="rect">
             <a:avLst/>
@@ -4250,88 +4250,27 @@
               </a:spcAft>
             </a:pPr>
             <a:r>
-              <a:rPr sz="1600" b="1">
+              <a:rPr sz="1500" b="1">
                 <a:solidFill>
                   <a:srgbClr val="FFFFFF"/>
                 </a:solidFill>
                 <a:latin typeface="Arial"/>
               </a:rPr>
-              <a:t>Goal: answer prospective card questions with grounded facts,</a:t>
-            </a:r>
-          </a:p>
-          <a:p>
-            <a:pPr algn="l">
-              <a:lnSpc>
-                <a:spcPct val="100000"/>
-              </a:lnSpc>
-              <a:spcAft>
-                <a:spcPts val="0"/>
-              </a:spcAft>
-            </a:pPr>
-            <a:r>
-              <a:rPr sz="1600" b="1">
-                <a:solidFill>
-                  <a:srgbClr val="FFFFFF"/>
-                </a:solidFill>
-                <a:latin typeface="Arial"/>
-              </a:rPr>
-              <a:t>then verify every action the agent claims it took.</a:t>
-            </a:r>
-          </a:p>
-        </p:txBody>
-      </p:sp>
-      <p:sp>
-        <p:nvSpPr>
-          <p:cNvPr id="14" name="TextBox 13"/>
-          <p:cNvSpPr txBox="1"/>
-          <p:nvPr/>
-        </p:nvSpPr>
-        <p:spPr>
-          <a:xfrm>
-            <a:off x="512064" y="2971800"/>
-            <a:ext cx="5349240" cy="274320"/>
-          </a:xfrm>
-          <a:prstGeom prst="rect">
-            <a:avLst/>
-          </a:prstGeom>
-          <a:noFill/>
-        </p:spPr>
-        <p:txBody>
-          <a:bodyPr wrap="square" lIns="0" rIns="0" tIns="0" bIns="0" anchor="t">
-            <a:spAutoFit/>
-          </a:bodyPr>
-          <a:lstStyle/>
-          <a:p>
-            <a:pPr algn="l">
-              <a:lnSpc>
-                <a:spcPct val="100000"/>
-              </a:lnSpc>
-              <a:spcAft>
-                <a:spcPts val="0"/>
-              </a:spcAft>
-            </a:pPr>
-            <a:r>
-              <a:rPr sz="1100" b="1">
-                <a:solidFill>
-                  <a:srgbClr val="176F70"/>
-                </a:solidFill>
-                <a:latin typeface="Arial"/>
-              </a:rPr>
-              <a:t>SUPPLIED DATA  /  WHY WE USE IT</a:t>
-            </a:r>
-          </a:p>
-        </p:txBody>
-      </p:sp>
-      <p:sp>
-        <p:nvSpPr>
-          <p:cNvPr id="15" name="Rounded Rectangle 14"/>
+              <a:t>Clear terms now  ·  relevant choices next  ·  verified status for every mock action</a:t>
+            </a:r>
+          </a:p>
+        </p:txBody>
+      </p:sp>
+      <p:sp>
+        <p:nvSpPr>
+          <p:cNvPr id="14" name="Rounded Rectangle 13"/>
           <p:cNvSpPr/>
           <p:nvPr/>
         </p:nvSpPr>
         <p:spPr>
           <a:xfrm>
-            <a:off x="512064" y="3337560"/>
-            <a:ext cx="5330952" cy="1161288"/>
+            <a:off x="512064" y="2907792"/>
+            <a:ext cx="2029968" cy="1719072"/>
           </a:xfrm>
           <a:prstGeom prst="roundRect">
             <a:avLst>
@@ -4371,14 +4310,14 @@
       </p:sp>
       <p:sp>
         <p:nvSpPr>
-          <p:cNvPr id="16" name="Rounded Rectangle 15"/>
+          <p:cNvPr id="15" name="Rounded Rectangle 14"/>
           <p:cNvSpPr/>
           <p:nvPr/>
         </p:nvSpPr>
         <p:spPr>
           <a:xfrm>
-            <a:off x="667512" y="3502152"/>
-            <a:ext cx="365760" cy="365760"/>
+            <a:off x="658368" y="3063240"/>
+            <a:ext cx="347472" cy="347472"/>
           </a:xfrm>
           <a:prstGeom prst="roundRect">
             <a:avLst>
@@ -4416,14 +4355,14 @@
       </p:sp>
       <p:sp>
         <p:nvSpPr>
-          <p:cNvPr id="17" name="TextBox 16"/>
+          <p:cNvPr id="16" name="TextBox 15"/>
           <p:cNvSpPr txBox="1"/>
           <p:nvPr/>
         </p:nvSpPr>
         <p:spPr>
           <a:xfrm>
-            <a:off x="667512" y="3589020"/>
-            <a:ext cx="365760" cy="109728"/>
+            <a:off x="658368" y="3154680"/>
+            <a:ext cx="347472" cy="109728"/>
           </a:xfrm>
           <a:prstGeom prst="rect">
             <a:avLst/>
@@ -4445,7 +4384,7 @@
               </a:spcAft>
             </a:pPr>
             <a:r>
-              <a:rPr sz="1100" b="1">
+              <a:rPr sz="1050" b="1">
                 <a:solidFill>
                   <a:srgbClr val="112B38"/>
                 </a:solidFill>
@@ -4458,14 +4397,14 @@
       </p:sp>
       <p:sp>
         <p:nvSpPr>
-          <p:cNvPr id="18" name="TextBox 17"/>
+          <p:cNvPr id="17" name="TextBox 16"/>
           <p:cNvSpPr txBox="1"/>
           <p:nvPr/>
         </p:nvSpPr>
         <p:spPr>
           <a:xfrm>
-            <a:off x="1152144" y="3520440"/>
-            <a:ext cx="4553712" cy="237744"/>
+            <a:off x="658368" y="3584448"/>
+            <a:ext cx="1737360" cy="274320"/>
           </a:xfrm>
           <a:prstGeom prst="rect">
             <a:avLst/>
@@ -4487,27 +4426,27 @@
               </a:spcAft>
             </a:pPr>
             <a:r>
-              <a:rPr sz="1400" b="1">
+              <a:rPr sz="1600" b="1">
                 <a:solidFill>
                   <a:srgbClr val="112B38"/>
                 </a:solidFill>
                 <a:latin typeface="Arial"/>
               </a:rPr>
-              <a:t>Campaigns + sends</a:t>
-            </a:r>
-          </a:p>
-        </p:txBody>
-      </p:sp>
-      <p:sp>
-        <p:nvSpPr>
-          <p:cNvPr id="19" name="TextBox 18"/>
+              <a:t>Ask</a:t>
+            </a:r>
+          </a:p>
+        </p:txBody>
+      </p:sp>
+      <p:sp>
+        <p:nvSpPr>
+          <p:cNvPr id="18" name="TextBox 17"/>
           <p:cNvSpPr txBox="1"/>
           <p:nvPr/>
         </p:nvSpPr>
         <p:spPr>
           <a:xfrm>
-            <a:off x="1152144" y="3840480"/>
-            <a:ext cx="4526280" cy="576072"/>
+            <a:off x="658368" y="3977639"/>
+            <a:ext cx="1737360" cy="502920"/>
           </a:xfrm>
           <a:prstGeom prst="rect">
             <a:avLst/>
@@ -4535,7 +4474,7 @@
                 </a:solidFill>
                 <a:latin typeface="Arial"/>
               </a:rPr>
-              <a:t>MARKETING_CAMPAIGNS + CAMPAIGN_SENDS: 52 generic</a:t>
+              <a:t>Fees and benefits</a:t>
             </a:r>
           </a:p>
           <a:p>
@@ -4554,8 +4493,55 @@
                 </a:solidFill>
                 <a:latin typeface="Arial"/>
               </a:rPr>
-              <a:t>credit campaigns; interest and entry context, not sales.</a:t>
-            </a:r>
+              <a:t>in natural language</a:t>
+            </a:r>
+          </a:p>
+        </p:txBody>
+      </p:sp>
+      <p:sp>
+        <p:nvSpPr>
+          <p:cNvPr id="19" name="Rounded Rectangle 18"/>
+          <p:cNvSpPr/>
+          <p:nvPr/>
+        </p:nvSpPr>
+        <p:spPr>
+          <a:xfrm>
+            <a:off x="2798064" y="2907792"/>
+            <a:ext cx="2029968" cy="1719072"/>
+          </a:xfrm>
+          <a:prstGeom prst="roundRect">
+            <a:avLst>
+              <a:gd name="adj" fmla="val 12000"/>
+            </a:avLst>
+          </a:prstGeom>
+          <a:solidFill>
+            <a:srgbClr val="E8F2F6"/>
+          </a:solidFill>
+          <a:ln w="12700">
+            <a:solidFill>
+              <a:srgbClr val="D7E3E1"/>
+            </a:solidFill>
+          </a:ln>
+        </p:spPr>
+        <p:style>
+          <a:lnRef idx="1">
+            <a:schemeClr val="accent1"/>
+          </a:lnRef>
+          <a:fillRef idx="3">
+            <a:schemeClr val="accent1"/>
+          </a:fillRef>
+          <a:effectRef idx="2">
+            <a:schemeClr val="accent1"/>
+          </a:effectRef>
+          <a:fontRef idx="minor">
+            <a:schemeClr val="lt1"/>
+          </a:fontRef>
+        </p:style>
+        <p:txBody>
+          <a:bodyPr rtlCol="0" anchor="ctr"/>
+          <a:lstStyle/>
+          <a:p>
+            <a:pPr algn="ctr"/>
           </a:p>
         </p:txBody>
       </p:sp>
@@ -4567,8 +4553,198 @@
         </p:nvSpPr>
         <p:spPr>
           <a:xfrm>
-            <a:off x="512064" y="4617720"/>
-            <a:ext cx="5330952" cy="1161288"/>
+            <a:off x="2944368" y="3063240"/>
+            <a:ext cx="347472" cy="347472"/>
+          </a:xfrm>
+          <a:prstGeom prst="roundRect">
+            <a:avLst>
+              <a:gd name="adj" fmla="val 12000"/>
+            </a:avLst>
+          </a:prstGeom>
+          <a:solidFill>
+            <a:srgbClr val="D5F377"/>
+          </a:solidFill>
+          <a:ln>
+            <a:noFill/>
+          </a:ln>
+        </p:spPr>
+        <p:style>
+          <a:lnRef idx="1">
+            <a:schemeClr val="accent1"/>
+          </a:lnRef>
+          <a:fillRef idx="3">
+            <a:schemeClr val="accent1"/>
+          </a:fillRef>
+          <a:effectRef idx="2">
+            <a:schemeClr val="accent1"/>
+          </a:effectRef>
+          <a:fontRef idx="minor">
+            <a:schemeClr val="lt1"/>
+          </a:fontRef>
+        </p:style>
+        <p:txBody>
+          <a:bodyPr rtlCol="0" anchor="ctr"/>
+          <a:lstStyle/>
+          <a:p>
+            <a:pPr algn="ctr"/>
+          </a:p>
+        </p:txBody>
+      </p:sp>
+      <p:sp>
+        <p:nvSpPr>
+          <p:cNvPr id="21" name="TextBox 20"/>
+          <p:cNvSpPr txBox="1"/>
+          <p:nvPr/>
+        </p:nvSpPr>
+        <p:spPr>
+          <a:xfrm>
+            <a:off x="2944368" y="3154680"/>
+            <a:ext cx="347472" cy="109728"/>
+          </a:xfrm>
+          <a:prstGeom prst="rect">
+            <a:avLst/>
+          </a:prstGeom>
+          <a:noFill/>
+        </p:spPr>
+        <p:txBody>
+          <a:bodyPr wrap="square" lIns="0" rIns="0" tIns="0" bIns="0" anchor="t">
+            <a:spAutoFit/>
+          </a:bodyPr>
+          <a:lstStyle/>
+          <a:p>
+            <a:pPr algn="ctr">
+              <a:lnSpc>
+                <a:spcPct val="100000"/>
+              </a:lnSpc>
+              <a:spcAft>
+                <a:spcPts val="0"/>
+              </a:spcAft>
+            </a:pPr>
+            <a:r>
+              <a:rPr sz="1050" b="1">
+                <a:solidFill>
+                  <a:srgbClr val="112B38"/>
+                </a:solidFill>
+                <a:latin typeface="Arial"/>
+              </a:rPr>
+              <a:t>2</a:t>
+            </a:r>
+          </a:p>
+        </p:txBody>
+      </p:sp>
+      <p:sp>
+        <p:nvSpPr>
+          <p:cNvPr id="22" name="TextBox 21"/>
+          <p:cNvSpPr txBox="1"/>
+          <p:nvPr/>
+        </p:nvSpPr>
+        <p:spPr>
+          <a:xfrm>
+            <a:off x="2944368" y="3584448"/>
+            <a:ext cx="1737360" cy="274320"/>
+          </a:xfrm>
+          <a:prstGeom prst="rect">
+            <a:avLst/>
+          </a:prstGeom>
+          <a:noFill/>
+        </p:spPr>
+        <p:txBody>
+          <a:bodyPr wrap="square" lIns="0" rIns="0" tIns="0" bIns="0" anchor="t">
+            <a:spAutoFit/>
+          </a:bodyPr>
+          <a:lstStyle/>
+          <a:p>
+            <a:pPr algn="l">
+              <a:lnSpc>
+                <a:spcPct val="100000"/>
+              </a:lnSpc>
+              <a:spcAft>
+                <a:spcPts val="0"/>
+              </a:spcAft>
+            </a:pPr>
+            <a:r>
+              <a:rPr sz="1600" b="1">
+                <a:solidFill>
+                  <a:srgbClr val="112B38"/>
+                </a:solidFill>
+                <a:latin typeface="Arial"/>
+              </a:rPr>
+              <a:t>Compare</a:t>
+            </a:r>
+          </a:p>
+        </p:txBody>
+      </p:sp>
+      <p:sp>
+        <p:nvSpPr>
+          <p:cNvPr id="23" name="TextBox 22"/>
+          <p:cNvSpPr txBox="1"/>
+          <p:nvPr/>
+        </p:nvSpPr>
+        <p:spPr>
+          <a:xfrm>
+            <a:off x="2944368" y="3977639"/>
+            <a:ext cx="1737360" cy="502920"/>
+          </a:xfrm>
+          <a:prstGeom prst="rect">
+            <a:avLst/>
+          </a:prstGeom>
+          <a:noFill/>
+        </p:spPr>
+        <p:txBody>
+          <a:bodyPr wrap="square" lIns="0" rIns="0" tIns="0" bIns="0" anchor="t">
+            <a:spAutoFit/>
+          </a:bodyPr>
+          <a:lstStyle/>
+          <a:p>
+            <a:pPr algn="l">
+              <a:lnSpc>
+                <a:spcPct val="100000"/>
+              </a:lnSpc>
+              <a:spcAft>
+                <a:spcPts val="0"/>
+              </a:spcAft>
+            </a:pPr>
+            <a:r>
+              <a:rPr sz="1030" b="0">
+                <a:solidFill>
+                  <a:srgbClr val="617780"/>
+                </a:solidFill>
+                <a:latin typeface="Arial"/>
+              </a:rPr>
+              <a:t>See options and</a:t>
+            </a:r>
+          </a:p>
+          <a:p>
+            <a:pPr algn="l">
+              <a:lnSpc>
+                <a:spcPct val="100000"/>
+              </a:lnSpc>
+              <a:spcAft>
+                <a:spcPts val="0"/>
+              </a:spcAft>
+            </a:pPr>
+            <a:r>
+              <a:rPr sz="1030" b="0">
+                <a:solidFill>
+                  <a:srgbClr val="617780"/>
+                </a:solidFill>
+                <a:latin typeface="Arial"/>
+              </a:rPr>
+              <a:t>their trade-offs</a:t>
+            </a:r>
+          </a:p>
+        </p:txBody>
+      </p:sp>
+      <p:sp>
+        <p:nvSpPr>
+          <p:cNvPr id="24" name="Rounded Rectangle 23"/>
+          <p:cNvSpPr/>
+          <p:nvPr/>
+        </p:nvSpPr>
+        <p:spPr>
+          <a:xfrm>
+            <a:off x="5084064" y="2907792"/>
+            <a:ext cx="2029968" cy="1719072"/>
           </a:xfrm>
           <a:prstGeom prst="roundRect">
             <a:avLst>
@@ -4608,14 +4784,14 @@
       </p:sp>
       <p:sp>
         <p:nvSpPr>
-          <p:cNvPr id="21" name="Rounded Rectangle 20"/>
+          <p:cNvPr id="25" name="Rounded Rectangle 24"/>
           <p:cNvSpPr/>
           <p:nvPr/>
         </p:nvSpPr>
         <p:spPr>
           <a:xfrm>
-            <a:off x="667512" y="4782312"/>
-            <a:ext cx="365760" cy="365760"/>
+            <a:off x="5230368" y="3063240"/>
+            <a:ext cx="347472" cy="347472"/>
           </a:xfrm>
           <a:prstGeom prst="roundRect">
             <a:avLst>
@@ -4653,14 +4829,14 @@
       </p:sp>
       <p:sp>
         <p:nvSpPr>
-          <p:cNvPr id="22" name="TextBox 21"/>
+          <p:cNvPr id="26" name="TextBox 25"/>
           <p:cNvSpPr txBox="1"/>
           <p:nvPr/>
         </p:nvSpPr>
         <p:spPr>
           <a:xfrm>
-            <a:off x="667512" y="4869180"/>
-            <a:ext cx="365760" cy="109728"/>
+            <a:off x="5230368" y="3154680"/>
+            <a:ext cx="347472" cy="109728"/>
           </a:xfrm>
           <a:prstGeom prst="rect">
             <a:avLst/>
@@ -4682,27 +4858,27 @@
               </a:spcAft>
             </a:pPr>
             <a:r>
-              <a:rPr sz="1100" b="1">
+              <a:rPr sz="1050" b="1">
                 <a:solidFill>
                   <a:srgbClr val="112B38"/>
                 </a:solidFill>
                 <a:latin typeface="Arial"/>
               </a:rPr>
-              <a:t>2</a:t>
-            </a:r>
-          </a:p>
-        </p:txBody>
-      </p:sp>
-      <p:sp>
-        <p:nvSpPr>
-          <p:cNvPr id="23" name="TextBox 22"/>
+              <a:t>3</a:t>
+            </a:r>
+          </a:p>
+        </p:txBody>
+      </p:sp>
+      <p:sp>
+        <p:nvSpPr>
+          <p:cNvPr id="27" name="TextBox 26"/>
           <p:cNvSpPr txBox="1"/>
           <p:nvPr/>
         </p:nvSpPr>
         <p:spPr>
           <a:xfrm>
-            <a:off x="1152144" y="4800600"/>
-            <a:ext cx="4553712" cy="237744"/>
+            <a:off x="5230368" y="3584448"/>
+            <a:ext cx="1737360" cy="274320"/>
           </a:xfrm>
           <a:prstGeom prst="rect">
             <a:avLst/>
@@ -4724,27 +4900,27 @@
               </a:spcAft>
             </a:pPr>
             <a:r>
-              <a:rPr sz="1400" b="1">
+              <a:rPr sz="1600" b="1">
                 <a:solidFill>
                   <a:srgbClr val="112B38"/>
                 </a:solidFill>
                 <a:latin typeface="Arial"/>
               </a:rPr>
-              <a:t>Customers + products</a:t>
-            </a:r>
-          </a:p>
-        </p:txBody>
-      </p:sp>
-      <p:sp>
-        <p:nvSpPr>
-          <p:cNvPr id="24" name="TextBox 23"/>
+              <a:t>Choose</a:t>
+            </a:r>
+          </a:p>
+        </p:txBody>
+      </p:sp>
+      <p:sp>
+        <p:nvSpPr>
+          <p:cNvPr id="28" name="TextBox 27"/>
           <p:cNvSpPr txBox="1"/>
           <p:nvPr/>
         </p:nvSpPr>
         <p:spPr>
           <a:xfrm>
-            <a:off x="1152144" y="5120640"/>
-            <a:ext cx="4526280" cy="576072"/>
+            <a:off x="5230368" y="3977639"/>
+            <a:ext cx="1737360" cy="502920"/>
           </a:xfrm>
           <a:prstGeom prst="rect">
             <a:avLst/>
@@ -4772,7 +4948,7 @@
                 </a:solidFill>
                 <a:latin typeface="Arial"/>
               </a:rPr>
-              <a:t>CUSTOMERS + PRODUCTS: local scenario profiles, country,</a:t>
+              <a:t>Keep the right card</a:t>
             </a:r>
           </a:p>
           <a:p>
@@ -4791,21 +4967,258 @@
                 </a:solidFill>
                 <a:latin typeface="Arial"/>
               </a:rPr>
-              <a:t>score, income estimate, and existing holdings.</a:t>
-            </a:r>
-          </a:p>
-        </p:txBody>
-      </p:sp>
-      <p:sp>
-        <p:nvSpPr>
-          <p:cNvPr id="25" name="Rounded Rectangle 24"/>
+              <a:t>in context</a:t>
+            </a:r>
+          </a:p>
+        </p:txBody>
+      </p:sp>
+      <p:sp>
+        <p:nvSpPr>
+          <p:cNvPr id="29" name="Rounded Rectangle 28"/>
           <p:cNvSpPr/>
           <p:nvPr/>
         </p:nvSpPr>
         <p:spPr>
           <a:xfrm>
-            <a:off x="6053328" y="3337560"/>
-            <a:ext cx="5632704" cy="1161288"/>
+            <a:off x="7370064" y="2907792"/>
+            <a:ext cx="2029968" cy="1719072"/>
+          </a:xfrm>
+          <a:prstGeom prst="roundRect">
+            <a:avLst>
+              <a:gd name="adj" fmla="val 12000"/>
+            </a:avLst>
+          </a:prstGeom>
+          <a:solidFill>
+            <a:srgbClr val="E9F4EE"/>
+          </a:solidFill>
+          <a:ln w="12700">
+            <a:solidFill>
+              <a:srgbClr val="D7E3E1"/>
+            </a:solidFill>
+          </a:ln>
+        </p:spPr>
+        <p:style>
+          <a:lnRef idx="1">
+            <a:schemeClr val="accent1"/>
+          </a:lnRef>
+          <a:fillRef idx="3">
+            <a:schemeClr val="accent1"/>
+          </a:fillRef>
+          <a:effectRef idx="2">
+            <a:schemeClr val="accent1"/>
+          </a:effectRef>
+          <a:fontRef idx="minor">
+            <a:schemeClr val="lt1"/>
+          </a:fontRef>
+        </p:style>
+        <p:txBody>
+          <a:bodyPr rtlCol="0" anchor="ctr"/>
+          <a:lstStyle/>
+          <a:p>
+            <a:pPr algn="ctr"/>
+          </a:p>
+        </p:txBody>
+      </p:sp>
+      <p:sp>
+        <p:nvSpPr>
+          <p:cNvPr id="30" name="Rounded Rectangle 29"/>
+          <p:cNvSpPr/>
+          <p:nvPr/>
+        </p:nvSpPr>
+        <p:spPr>
+          <a:xfrm>
+            <a:off x="7516368" y="3063240"/>
+            <a:ext cx="347472" cy="347472"/>
+          </a:xfrm>
+          <a:prstGeom prst="roundRect">
+            <a:avLst>
+              <a:gd name="adj" fmla="val 12000"/>
+            </a:avLst>
+          </a:prstGeom>
+          <a:solidFill>
+            <a:srgbClr val="D5F377"/>
+          </a:solidFill>
+          <a:ln>
+            <a:noFill/>
+          </a:ln>
+        </p:spPr>
+        <p:style>
+          <a:lnRef idx="1">
+            <a:schemeClr val="accent1"/>
+          </a:lnRef>
+          <a:fillRef idx="3">
+            <a:schemeClr val="accent1"/>
+          </a:fillRef>
+          <a:effectRef idx="2">
+            <a:schemeClr val="accent1"/>
+          </a:effectRef>
+          <a:fontRef idx="minor">
+            <a:schemeClr val="lt1"/>
+          </a:fontRef>
+        </p:style>
+        <p:txBody>
+          <a:bodyPr rtlCol="0" anchor="ctr"/>
+          <a:lstStyle/>
+          <a:p>
+            <a:pPr algn="ctr"/>
+          </a:p>
+        </p:txBody>
+      </p:sp>
+      <p:sp>
+        <p:nvSpPr>
+          <p:cNvPr id="31" name="TextBox 30"/>
+          <p:cNvSpPr txBox="1"/>
+          <p:nvPr/>
+        </p:nvSpPr>
+        <p:spPr>
+          <a:xfrm>
+            <a:off x="7516368" y="3154680"/>
+            <a:ext cx="347472" cy="109728"/>
+          </a:xfrm>
+          <a:prstGeom prst="rect">
+            <a:avLst/>
+          </a:prstGeom>
+          <a:noFill/>
+        </p:spPr>
+        <p:txBody>
+          <a:bodyPr wrap="square" lIns="0" rIns="0" tIns="0" bIns="0" anchor="t">
+            <a:spAutoFit/>
+          </a:bodyPr>
+          <a:lstStyle/>
+          <a:p>
+            <a:pPr algn="ctr">
+              <a:lnSpc>
+                <a:spcPct val="100000"/>
+              </a:lnSpc>
+              <a:spcAft>
+                <a:spcPts val="0"/>
+              </a:spcAft>
+            </a:pPr>
+            <a:r>
+              <a:rPr sz="1050" b="1">
+                <a:solidFill>
+                  <a:srgbClr val="112B38"/>
+                </a:solidFill>
+                <a:latin typeface="Arial"/>
+              </a:rPr>
+              <a:t>4</a:t>
+            </a:r>
+          </a:p>
+        </p:txBody>
+      </p:sp>
+      <p:sp>
+        <p:nvSpPr>
+          <p:cNvPr id="32" name="TextBox 31"/>
+          <p:cNvSpPr txBox="1"/>
+          <p:nvPr/>
+        </p:nvSpPr>
+        <p:spPr>
+          <a:xfrm>
+            <a:off x="7516368" y="3584448"/>
+            <a:ext cx="1737360" cy="274320"/>
+          </a:xfrm>
+          <a:prstGeom prst="rect">
+            <a:avLst/>
+          </a:prstGeom>
+          <a:noFill/>
+        </p:spPr>
+        <p:txBody>
+          <a:bodyPr wrap="square" lIns="0" rIns="0" tIns="0" bIns="0" anchor="t">
+            <a:spAutoFit/>
+          </a:bodyPr>
+          <a:lstStyle/>
+          <a:p>
+            <a:pPr algn="l">
+              <a:lnSpc>
+                <a:spcPct val="100000"/>
+              </a:lnSpc>
+              <a:spcAft>
+                <a:spcPts val="0"/>
+              </a:spcAft>
+            </a:pPr>
+            <a:r>
+              <a:rPr sz="1600" b="1">
+                <a:solidFill>
+                  <a:srgbClr val="112B38"/>
+                </a:solidFill>
+                <a:latin typeface="Arial"/>
+              </a:rPr>
+              <a:t>Consent</a:t>
+            </a:r>
+          </a:p>
+        </p:txBody>
+      </p:sp>
+      <p:sp>
+        <p:nvSpPr>
+          <p:cNvPr id="33" name="TextBox 32"/>
+          <p:cNvSpPr txBox="1"/>
+          <p:nvPr/>
+        </p:nvSpPr>
+        <p:spPr>
+          <a:xfrm>
+            <a:off x="7516368" y="3977639"/>
+            <a:ext cx="1737360" cy="502920"/>
+          </a:xfrm>
+          <a:prstGeom prst="rect">
+            <a:avLst/>
+          </a:prstGeom>
+          <a:noFill/>
+        </p:spPr>
+        <p:txBody>
+          <a:bodyPr wrap="square" lIns="0" rIns="0" tIns="0" bIns="0" anchor="t">
+            <a:spAutoFit/>
+          </a:bodyPr>
+          <a:lstStyle/>
+          <a:p>
+            <a:pPr algn="l">
+              <a:lnSpc>
+                <a:spcPct val="100000"/>
+              </a:lnSpc>
+              <a:spcAft>
+                <a:spcPts val="0"/>
+              </a:spcAft>
+            </a:pPr>
+            <a:r>
+              <a:rPr sz="1030" b="0">
+                <a:solidFill>
+                  <a:srgbClr val="617780"/>
+                </a:solidFill>
+                <a:latin typeface="Arial"/>
+              </a:rPr>
+              <a:t>Allow an optional</a:t>
+            </a:r>
+          </a:p>
+          <a:p>
+            <a:pPr algn="l">
+              <a:lnSpc>
+                <a:spcPct val="100000"/>
+              </a:lnSpc>
+              <a:spcAft>
+                <a:spcPts val="0"/>
+              </a:spcAft>
+            </a:pPr>
+            <a:r>
+              <a:rPr sz="1030" b="0">
+                <a:solidFill>
+                  <a:srgbClr val="617780"/>
+                </a:solidFill>
+                <a:latin typeface="Arial"/>
+              </a:rPr>
+              <a:t>card-specific precheck</a:t>
+            </a:r>
+          </a:p>
+        </p:txBody>
+      </p:sp>
+      <p:sp>
+        <p:nvSpPr>
+          <p:cNvPr id="34" name="Rounded Rectangle 33"/>
+          <p:cNvSpPr/>
+          <p:nvPr/>
+        </p:nvSpPr>
+        <p:spPr>
+          <a:xfrm>
+            <a:off x="9656064" y="2907792"/>
+            <a:ext cx="2029968" cy="1719072"/>
           </a:xfrm>
           <a:prstGeom prst="roundRect">
             <a:avLst>
@@ -4845,14 +5258,14 @@
       </p:sp>
       <p:sp>
         <p:nvSpPr>
-          <p:cNvPr id="26" name="Rounded Rectangle 25"/>
+          <p:cNvPr id="35" name="Rounded Rectangle 34"/>
           <p:cNvSpPr/>
           <p:nvPr/>
         </p:nvSpPr>
         <p:spPr>
           <a:xfrm>
-            <a:off x="6208776" y="3502152"/>
-            <a:ext cx="365760" cy="365760"/>
+            <a:off x="9802368" y="3063240"/>
+            <a:ext cx="347472" cy="347472"/>
           </a:xfrm>
           <a:prstGeom prst="roundRect">
             <a:avLst>
@@ -4890,14 +5303,14 @@
       </p:sp>
       <p:sp>
         <p:nvSpPr>
-          <p:cNvPr id="27" name="TextBox 26"/>
+          <p:cNvPr id="36" name="TextBox 35"/>
           <p:cNvSpPr txBox="1"/>
           <p:nvPr/>
         </p:nvSpPr>
         <p:spPr>
           <a:xfrm>
-            <a:off x="6208776" y="3589020"/>
-            <a:ext cx="365760" cy="109728"/>
+            <a:off x="9802368" y="3154680"/>
+            <a:ext cx="347472" cy="109728"/>
           </a:xfrm>
           <a:prstGeom prst="rect">
             <a:avLst/>
@@ -4919,27 +5332,27 @@
               </a:spcAft>
             </a:pPr>
             <a:r>
-              <a:rPr sz="1100" b="1">
+              <a:rPr sz="1050" b="1">
                 <a:solidFill>
                   <a:srgbClr val="112B38"/>
                 </a:solidFill>
                 <a:latin typeface="Arial"/>
               </a:rPr>
-              <a:t>3</a:t>
-            </a:r>
-          </a:p>
-        </p:txBody>
-      </p:sp>
-      <p:sp>
-        <p:nvSpPr>
-          <p:cNvPr id="28" name="TextBox 27"/>
+              <a:t>5</a:t>
+            </a:r>
+          </a:p>
+        </p:txBody>
+      </p:sp>
+      <p:sp>
+        <p:nvSpPr>
+          <p:cNvPr id="37" name="TextBox 36"/>
           <p:cNvSpPr txBox="1"/>
           <p:nvPr/>
         </p:nvSpPr>
         <p:spPr>
           <a:xfrm>
-            <a:off x="6693408" y="3520440"/>
-            <a:ext cx="4855464" cy="237744"/>
+            <a:off x="9802368" y="3584448"/>
+            <a:ext cx="1737360" cy="274320"/>
           </a:xfrm>
           <a:prstGeom prst="rect">
             <a:avLst/>
@@ -4961,27 +5374,27 @@
               </a:spcAft>
             </a:pPr>
             <a:r>
-              <a:rPr sz="1400" b="1">
+              <a:rPr sz="1600" b="1">
                 <a:solidFill>
                   <a:srgbClr val="112B38"/>
                 </a:solidFill>
                 <a:latin typeface="Arial"/>
               </a:rPr>
-              <a:t>Service agents + transcripts</a:t>
-            </a:r>
-          </a:p>
-        </p:txBody>
-      </p:sp>
-      <p:sp>
-        <p:nvSpPr>
-          <p:cNvPr id="29" name="TextBox 28"/>
+              <a:t>Next step</a:t>
+            </a:r>
+          </a:p>
+        </p:txBody>
+      </p:sp>
+      <p:sp>
+        <p:nvSpPr>
+          <p:cNvPr id="38" name="TextBox 37"/>
           <p:cNvSpPr txBox="1"/>
           <p:nvPr/>
         </p:nvSpPr>
         <p:spPr>
           <a:xfrm>
-            <a:off x="6693408" y="3840480"/>
-            <a:ext cx="4828032" cy="576072"/>
+            <a:off x="9802368" y="3977639"/>
+            <a:ext cx="1737360" cy="502920"/>
           </a:xfrm>
           <a:prstGeom prst="rect">
             <a:avLst/>
@@ -5009,7 +5422,7 @@
                 </a:solidFill>
                 <a:latin typeface="Arial"/>
               </a:rPr>
-              <a:t>SERVICE_AGENTS: language-based mock routing.</a:t>
+              <a:t>Confirm a mock request</a:t>
             </a:r>
           </a:p>
           <a:p>
@@ -5028,21 +5441,21 @@
                 </a:solidFill>
                 <a:latin typeface="Arial"/>
               </a:rPr>
-              <a:t>CALL_TRANSCRIPTS: Spanish tone, not facts.</a:t>
-            </a:r>
-          </a:p>
-        </p:txBody>
-      </p:sp>
-      <p:sp>
-        <p:nvSpPr>
-          <p:cNvPr id="30" name="Rounded Rectangle 29"/>
+              <a:t>or ask for review</a:t>
+            </a:r>
+          </a:p>
+        </p:txBody>
+      </p:sp>
+      <p:sp>
+        <p:nvSpPr>
+          <p:cNvPr id="39" name="Rounded Rectangle 38"/>
           <p:cNvSpPr/>
           <p:nvPr/>
         </p:nvSpPr>
         <p:spPr>
           <a:xfrm>
-            <a:off x="6053328" y="4617720"/>
-            <a:ext cx="5632704" cy="1161288"/>
+            <a:off x="512064" y="4965192"/>
+            <a:ext cx="11173968" cy="557784"/>
           </a:xfrm>
           <a:prstGeom prst="roundRect">
             <a:avLst>
@@ -5082,59 +5495,14 @@
       </p:sp>
       <p:sp>
         <p:nvSpPr>
-          <p:cNvPr id="31" name="Rounded Rectangle 30"/>
-          <p:cNvSpPr/>
-          <p:nvPr/>
-        </p:nvSpPr>
-        <p:spPr>
-          <a:xfrm>
-            <a:off x="6208776" y="4782312"/>
-            <a:ext cx="365760" cy="365760"/>
-          </a:xfrm>
-          <a:prstGeom prst="roundRect">
-            <a:avLst>
-              <a:gd name="adj" fmla="val 12000"/>
-            </a:avLst>
-          </a:prstGeom>
-          <a:solidFill>
-            <a:srgbClr val="D5F377"/>
-          </a:solidFill>
-          <a:ln>
-            <a:noFill/>
-          </a:ln>
-        </p:spPr>
-        <p:style>
-          <a:lnRef idx="1">
-            <a:schemeClr val="accent1"/>
-          </a:lnRef>
-          <a:fillRef idx="3">
-            <a:schemeClr val="accent1"/>
-          </a:fillRef>
-          <a:effectRef idx="2">
-            <a:schemeClr val="accent1"/>
-          </a:effectRef>
-          <a:fontRef idx="minor">
-            <a:schemeClr val="lt1"/>
-          </a:fontRef>
-        </p:style>
-        <p:txBody>
-          <a:bodyPr rtlCol="0" anchor="ctr"/>
-          <a:lstStyle/>
-          <a:p>
-            <a:pPr algn="ctr"/>
-          </a:p>
-        </p:txBody>
-      </p:sp>
-      <p:sp>
-        <p:nvSpPr>
-          <p:cNvPr id="32" name="TextBox 31"/>
+          <p:cNvPr id="40" name="TextBox 39"/>
           <p:cNvSpPr txBox="1"/>
           <p:nvPr/>
         </p:nvSpPr>
         <p:spPr>
           <a:xfrm>
-            <a:off x="6208776" y="4869180"/>
-            <a:ext cx="365760" cy="109728"/>
+            <a:off x="713232" y="5129784"/>
+            <a:ext cx="10789920" cy="228600"/>
           </a:xfrm>
           <a:prstGeom prst="rect">
             <a:avLst/>
@@ -5147,36 +5515,36 @@
           </a:bodyPr>
           <a:lstStyle/>
           <a:p>
-            <a:pPr algn="ctr">
-              <a:lnSpc>
-                <a:spcPct val="100000"/>
-              </a:lnSpc>
-              <a:spcAft>
-                <a:spcPts val="0"/>
-              </a:spcAft>
-            </a:pPr>
-            <a:r>
-              <a:rPr sz="1100" b="1">
-                <a:solidFill>
-                  <a:srgbClr val="112B38"/>
-                </a:solidFill>
-                <a:latin typeface="Arial"/>
-              </a:rPr>
-              <a:t>4</a:t>
-            </a:r>
-          </a:p>
-        </p:txBody>
-      </p:sp>
-      <p:sp>
-        <p:nvSpPr>
-          <p:cNvPr id="33" name="TextBox 32"/>
+            <a:pPr algn="l">
+              <a:lnSpc>
+                <a:spcPct val="100000"/>
+              </a:lnSpc>
+              <a:spcAft>
+                <a:spcPts val="0"/>
+              </a:spcAft>
+            </a:pPr>
+            <a:r>
+              <a:rPr sz="1120" b="1">
+                <a:solidFill>
+                  <a:srgbClr val="176F70"/>
+                </a:solidFill>
+                <a:latin typeface="Arial"/>
+              </a:rPr>
+              <a:t>Four choices: Campus for students  ·  Horizon for daily use  ·  Rewards for travel  ·  Summit for premium travel</a:t>
+            </a:r>
+          </a:p>
+        </p:txBody>
+      </p:sp>
+      <p:sp>
+        <p:nvSpPr>
+          <p:cNvPr id="41" name="TextBox 40"/>
           <p:cNvSpPr txBox="1"/>
           <p:nvPr/>
         </p:nvSpPr>
         <p:spPr>
           <a:xfrm>
-            <a:off x="6693408" y="4800600"/>
-            <a:ext cx="4855464" cy="237744"/>
+            <a:off x="512064" y="5733288"/>
+            <a:ext cx="11082528" cy="365760"/>
           </a:xfrm>
           <a:prstGeom prst="rect">
             <a:avLst/>
@@ -5198,116 +5566,32 @@
               </a:spcAft>
             </a:pPr>
             <a:r>
-              <a:rPr sz="1400" b="1">
-                <a:solidFill>
-                  <a:srgbClr val="112B38"/>
-                </a:solidFill>
-                <a:latin typeface="Arial"/>
-              </a:rPr>
-              <a:t>Team-created demo assets</a:t>
-            </a:r>
-          </a:p>
-        </p:txBody>
-      </p:sp>
-      <p:sp>
-        <p:nvSpPr>
-          <p:cNvPr id="34" name="TextBox 33"/>
-          <p:cNvSpPr txBox="1"/>
-          <p:nvPr/>
-        </p:nvSpPr>
-        <p:spPr>
-          <a:xfrm>
-            <a:off x="6693408" y="5120640"/>
-            <a:ext cx="4828032" cy="576072"/>
-          </a:xfrm>
-          <a:prstGeom prst="rect">
-            <a:avLst/>
-          </a:prstGeom>
-          <a:noFill/>
-        </p:spPr>
-        <p:txBody>
-          <a:bodyPr wrap="square" lIns="0" rIns="0" tIns="0" bIns="0" anchor="t">
-            <a:spAutoFit/>
-          </a:bodyPr>
-          <a:lstStyle/>
-          <a:p>
-            <a:pPr algn="l">
-              <a:lnSpc>
-                <a:spcPct val="100000"/>
-              </a:lnSpc>
-              <a:spcAft>
-                <a:spcPts val="0"/>
-              </a:spcAft>
-            </a:pPr>
-            <a:r>
-              <a:rPr sz="1030" b="0">
+              <a:rPr sz="900" b="0">
                 <a:solidFill>
                   <a:srgbClr val="617780"/>
                 </a:solidFill>
                 <a:latin typeface="Arial"/>
               </a:rPr>
-              <a:t>Four offer terms, synthetic policy, fictional public fixtures,</a:t>
-            </a:r>
-          </a:p>
-          <a:p>
-            <a:pPr algn="l">
-              <a:lnSpc>
-                <a:spcPct val="100000"/>
-              </a:lnSpc>
-              <a:spcAft>
-                <a:spcPts val="0"/>
-              </a:spcAft>
-            </a:pPr>
-            <a:r>
-              <a:rPr sz="1030" b="0">
+              <a:t>Data → value: campaigns shape entry; customer/product rows shape local tests; agent records shape mock routing; transcripts guide tone.</a:t>
+            </a:r>
+          </a:p>
+          <a:p>
+            <a:pPr algn="l">
+              <a:lnSpc>
+                <a:spcPct val="100000"/>
+              </a:lnSpc>
+              <a:spcAft>
+                <a:spcPts val="0"/>
+              </a:spcAft>
+            </a:pPr>
+            <a:r>
+              <a:rPr sz="900" b="0">
                 <a:solidFill>
                   <a:srgbClr val="617780"/>
                 </a:solidFill>
                 <a:latin typeface="Arial"/>
               </a:rPr>
-              <a:t>new chat events, and mock application/handoff records.</a:t>
-            </a:r>
-          </a:p>
-        </p:txBody>
-      </p:sp>
-      <p:sp>
-        <p:nvSpPr>
-          <p:cNvPr id="35" name="TextBox 34"/>
-          <p:cNvSpPr txBox="1"/>
-          <p:nvPr/>
-        </p:nvSpPr>
-        <p:spPr>
-          <a:xfrm>
-            <a:off x="512064" y="6044184"/>
-            <a:ext cx="11064240" cy="228600"/>
-          </a:xfrm>
-          <a:prstGeom prst="rect">
-            <a:avLst/>
-          </a:prstGeom>
-          <a:noFill/>
-        </p:spPr>
-        <p:txBody>
-          <a:bodyPr wrap="square" lIns="0" rIns="0" tIns="0" bIns="0" anchor="t">
-            <a:spAutoFit/>
-          </a:bodyPr>
-          <a:lstStyle/>
-          <a:p>
-            <a:pPr algn="l">
-              <a:lnSpc>
-                <a:spcPct val="100000"/>
-              </a:lnSpc>
-              <a:spcAft>
-                <a:spcPts val="0"/>
-              </a:spcAft>
-            </a:pPr>
-            <a:r>
-              <a:rPr sz="950" b="0">
-                <a:solidFill>
-                  <a:srgbClr val="617780"/>
-                </a:solidFill>
-                <a:latin typeface="Arial"/>
-              </a:rPr>
-              <a:t>Evidence boundary: 1.75M sends and 97.8K clicks cover all supplied campaigns; neither proves card acquisition or chatbot demand.</a:t>
+              <a:t>Public fixtures, offers, policy, and actions are team-created. Historical clicks show engagement, not card sales.</a:t>
             </a:r>
           </a:p>
         </p:txBody>
@@ -5706,7 +5990,7 @@
                 </a:solidFill>
                 <a:latin typeface="Arial"/>
               </a:rPr>
-              <a:t>A real conversation in Spanish</a:t>
+              <a:t>See a live card question answered in Spanish</a:t>
             </a:r>
           </a:p>
         </p:txBody>
@@ -5906,7 +6190,7 @@
                 </a:solidFill>
                 <a:latin typeface="Arial"/>
               </a:rPr>
-              <a:t>What this</a:t>
+              <a:t>Customer</a:t>
             </a:r>
           </a:p>
           <a:p>
@@ -5925,7 +6209,7 @@
                 </a:solidFill>
                 <a:latin typeface="Arial"/>
               </a:rPr>
-              <a:t>shows</a:t>
+              <a:t>value</a:t>
             </a:r>
           </a:p>
         </p:txBody>
@@ -6010,7 +6294,7 @@
                 </a:solidFill>
                 <a:latin typeface="Arial"/>
               </a:rPr>
-              <a:t>Maintains the</a:t>
+              <a:t>Selected card</a:t>
             </a:r>
           </a:p>
           <a:p>
@@ -6029,7 +6313,7 @@
                 </a:solidFill>
                 <a:latin typeface="Arial"/>
               </a:rPr>
-              <a:t>selected card</a:t>
+              <a:t>stays in context</a:t>
             </a:r>
           </a:p>
         </p:txBody>
@@ -6071,7 +6355,7 @@
                 </a:solidFill>
                 <a:latin typeface="Arial"/>
               </a:rPr>
-              <a:t>Answers a</a:t>
+              <a:t>Follow-up gets</a:t>
             </a:r>
           </a:p>
           <a:p>
@@ -6090,7 +6374,7 @@
                 </a:solidFill>
                 <a:latin typeface="Arial"/>
               </a:rPr>
-              <a:t>follow-up</a:t>
+              <a:t>an answer</a:t>
             </a:r>
           </a:p>
         </p:txBody>
@@ -6132,7 +6416,7 @@
                 </a:solidFill>
                 <a:latin typeface="Arial"/>
               </a:rPr>
-              <a:t>Displays source</a:t>
+              <a:t>Source IDs make</a:t>
             </a:r>
           </a:p>
           <a:p>
@@ -6151,7 +6435,7 @@
                 </a:solidFill>
                 <a:latin typeface="Arial"/>
               </a:rPr>
-              <a:t>fact IDs</a:t>
+              <a:t>claims traceable</a:t>
             </a:r>
           </a:p>
         </p:txBody>
@@ -6193,7 +6477,7 @@
                 </a:solidFill>
                 <a:latin typeface="Arial"/>
               </a:rPr>
-              <a:t>Live output; not a script</a:t>
+              <a:t>Live fictional-fixture chat</a:t>
             </a:r>
           </a:p>
         </p:txBody>
@@ -6592,7 +6876,7 @@
                 </a:solidFill>
                 <a:latin typeface="Arial"/>
               </a:rPr>
-              <a:t>Claude routes and answers; the service controls actions</a:t>
+              <a:t>How Atlas turns a question into a safe next step</a:t>
             </a:r>
           </a:p>
         </p:txBody>
@@ -6634,7 +6918,7 @@
                 </a:solidFill>
                 <a:latin typeface="Arial"/>
               </a:rPr>
-              <a:t>A bounded intent choice comes before service-owned policy, consent, and durable outcomes.</a:t>
+              <a:t>Each part supports the journey: understand intent, ground facts, protect consent, and verify actions.</a:t>
             </a:r>
           </a:p>
         </p:txBody>
@@ -6723,7 +7007,7 @@
                 </a:solidFill>
                 <a:latin typeface="Arial"/>
               </a:rPr>
-              <a:t>Browser</a:t>
+              <a:t>Customer starts</a:t>
             </a:r>
           </a:p>
         </p:txBody>
@@ -6784,7 +7068,7 @@
                 </a:solidFill>
                 <a:latin typeface="Arial"/>
               </a:rPr>
-              <a:t>Fictional fixture</a:t>
+              <a:t>Fictional demo customer</a:t>
             </a:r>
           </a:p>
         </p:txBody>
@@ -6915,7 +7199,7 @@
                 </a:solidFill>
                 <a:latin typeface="Arial"/>
               </a:rPr>
-              <a:t>HTTPS API + session</a:t>
+              <a:t>Keeps the active card</a:t>
             </a:r>
           </a:p>
           <a:p>
@@ -6934,7 +7218,7 @@
                 </a:solidFill>
                 <a:latin typeface="Arial"/>
               </a:rPr>
-              <a:t>Protected review route</a:t>
+              <a:t>Checks access + limits</a:t>
             </a:r>
           </a:p>
         </p:txBody>
@@ -7023,7 +7307,7 @@
                 </a:solidFill>
                 <a:latin typeface="Arial"/>
               </a:rPr>
-              <a:t>Conversation router</a:t>
+              <a:t>Haiku intent</a:t>
             </a:r>
           </a:p>
         </p:txBody>
@@ -7065,7 +7349,7 @@
                 </a:solidFill>
                 <a:latin typeface="Arial"/>
               </a:rPr>
-              <a:t>Haiku: bounded intent</a:t>
+              <a:t>Fact / compare / apply</a:t>
             </a:r>
           </a:p>
           <a:p>
@@ -7084,7 +7368,7 @@
                 </a:solidFill>
                 <a:latin typeface="Arial"/>
               </a:rPr>
-              <a:t>Service validates session</a:t>
+              <a:t>No private score sent</a:t>
             </a:r>
           </a:p>
         </p:txBody>
@@ -7255,7 +7539,7 @@
                 </a:solidFill>
                 <a:latin typeface="Arial"/>
               </a:rPr>
-              <a:t>DynamoDB state</a:t>
+              <a:t>Durable state</a:t>
             </a:r>
           </a:p>
         </p:txBody>
@@ -7297,7 +7581,7 @@
                 </a:solidFill>
                 <a:latin typeface="Arial"/>
               </a:rPr>
-              <a:t>Sessions + quota</a:t>
+              <a:t>DynamoDB sessions</a:t>
             </a:r>
           </a:p>
           <a:p>
@@ -7316,7 +7600,7 @@
                 </a:solidFill>
                 <a:latin typeface="Arial"/>
               </a:rPr>
-              <a:t>Actions + roster</a:t>
+              <a:t>Mock actions + read-back</a:t>
             </a:r>
           </a:p>
         </p:txBody>
@@ -7447,7 +7731,7 @@
                 </a:solidFill>
                 <a:latin typeface="Arial"/>
               </a:rPr>
-              <a:t>Product answers</a:t>
+              <a:t>Useful answers</a:t>
             </a:r>
           </a:p>
         </p:txBody>
@@ -7508,7 +7792,7 @@
                 </a:solidFill>
                 <a:latin typeface="Arial"/>
               </a:rPr>
-              <a:t>Citations checked; unknown → offer review</a:t>
+              <a:t>Source IDs trace product claims</a:t>
             </a:r>
           </a:p>
         </p:txBody>
@@ -7597,7 +7881,7 @@
                 </a:solidFill>
                 <a:latin typeface="Arial"/>
               </a:rPr>
-              <a:t>Deterministic policy</a:t>
+              <a:t>Controlled suggestion</a:t>
             </a:r>
           </a:p>
         </p:txBody>
@@ -7639,7 +7923,7 @@
                 </a:solidFill>
                 <a:latin typeface="Arial"/>
               </a:rPr>
-              <a:t>Fixture-bound suggestions</a:t>
+              <a:t>Selected fixture → policy suggestion</a:t>
             </a:r>
           </a:p>
           <a:p>
@@ -7658,7 +7942,7 @@
                 </a:solidFill>
                 <a:latin typeface="Arial"/>
               </a:rPr>
-              <a:t>Consented synthetic precheck</a:t>
+              <a:t>Consent → synthetic precheck</a:t>
             </a:r>
           </a:p>
           <a:p>
@@ -7677,7 +7961,7 @@
                 </a:solidFill>
                 <a:latin typeface="Arial"/>
               </a:rPr>
-              <a:t>The model cannot approve credit</a:t>
+              <a:t>No automatic approval</a:t>
             </a:r>
           </a:p>
         </p:txBody>
@@ -7766,7 +8050,7 @@
                 </a:solidFill>
                 <a:latin typeface="Arial"/>
               </a:rPr>
-              <a:t>Verified actions + reviewer</a:t>
+              <a:t>Verified next step</a:t>
             </a:r>
           </a:p>
         </p:txBody>
@@ -7808,7 +8092,7 @@
                 </a:solidFill>
                 <a:latin typeface="Arial"/>
               </a:rPr>
-              <a:t>Confirmation → write once → read back</a:t>
+              <a:t>Separate confirmation → write → read back</a:t>
             </a:r>
           </a:p>
           <a:p>
@@ -7827,7 +8111,7 @@
                 </a:solidFill>
                 <a:latin typeface="Arial"/>
               </a:rPr>
-              <a:t>Application: PENDING_REVIEW</a:t>
+              <a:t>Mock application: PENDING_REVIEW</a:t>
             </a:r>
           </a:p>
           <a:p>
@@ -7933,7 +8217,7 @@
                 </a:solidFill>
                 <a:latin typeface="Arial"/>
               </a:rPr>
-              <a:t>Boundaries: no private profile in model requests  ·  secrets in AWS SSM  ·  sanitized CloudWatch logs  ·  no bank write</a:t>
+              <a:t>Trust: private score stays in the service  ·  card-specific consent gates precheck  ·  read-back gates success claims</a:t>
             </a:r>
           </a:p>
         </p:txBody>
@@ -8332,7 +8616,7 @@
                 </a:solidFill>
                 <a:latin typeface="Arial"/>
               </a:rPr>
-              <a:t>87 automated tests passed; 7/8 live flows met expectations*</a:t>
+              <a:t>A working journey, backed by measured checks</a:t>
             </a:r>
           </a:p>
         </p:txBody>
@@ -8374,7 +8658,7 @@
                 </a:solidFill>
                 <a:latin typeface="Arial"/>
               </a:rPr>
-              <a:t>Current 4 October build · agent-run production smoke checks.</a:t>
+              <a:t>Current 4 October build · product and safety paths checked in production.</a:t>
             </a:r>
           </a:p>
         </p:txBody>
@@ -9318,7 +9602,7 @@
                 </a:solidFill>
                 <a:latin typeface="Arial"/>
               </a:rPr>
-              <a:t>Dated evidence + capacity</a:t>
+              <a:t>Checks behind the demo</a:t>
             </a:r>
           </a:p>
         </p:txBody>
@@ -9970,7 +10254,7 @@
                 </a:solidFill>
                 <a:latin typeface="Arial"/>
               </a:rPr>
-              <a:t>What changes before a customer can rely on it</a:t>
+              <a:t>From judge demo to a bank-ready advisor</a:t>
             </a:r>
           </a:p>
         </p:txBody>
@@ -10012,7 +10296,7 @@
                 </a:solidFill>
                 <a:latin typeface="Arial"/>
               </a:rPr>
-              <a:t>The prototype proves a workflow; a banking deployment needs approved data, live operations, and independent validation.</a:t>
+              <a:t>The same journey can serve real customers when its facts, identity, and human support are bank-operated.</a:t>
             </a:r>
           </a:p>
         </p:txBody>
@@ -10188,7 +10472,7 @@
                 </a:solidFill>
                 <a:latin typeface="Arial"/>
               </a:rPr>
-              <a:t>Approved products + policy</a:t>
+              <a:t>Accurate live offers</a:t>
             </a:r>
           </a:p>
         </p:txBody>
@@ -10230,7 +10514,7 @@
                 </a:solidFill>
                 <a:latin typeface="Arial"/>
               </a:rPr>
-              <a:t>Replace demo offers and thresholds with governed,</a:t>
+              <a:t>Governed card terms and credit policy replace</a:t>
             </a:r>
           </a:p>
           <a:p>
@@ -10249,7 +10533,7 @@
                 </a:solidFill>
                 <a:latin typeface="Arial"/>
               </a:rPr>
-              <a:t>versioned bank terms and credit policy; legal review.</a:t>
+              <a:t>team-created demo offers and thresholds.</a:t>
             </a:r>
           </a:p>
         </p:txBody>
@@ -10425,7 +10709,7 @@
                 </a:solidFill>
                 <a:latin typeface="Arial"/>
               </a:rPr>
-              <a:t>Identity + data permissions</a:t>
+              <a:t>Trusted customer context</a:t>
             </a:r>
           </a:p>
         </p:txBody>
@@ -10467,7 +10751,7 @@
                 </a:solidFill>
                 <a:latin typeface="Arial"/>
               </a:rPr>
-              <a:t>Real customer authentication, consent, current</a:t>
+              <a:t>Verified identity, permission, and current account</a:t>
             </a:r>
           </a:p>
           <a:p>
@@ -10486,7 +10770,7 @@
                 </a:solidFill>
                 <a:latin typeface="Arial"/>
               </a:rPr>
-              <a:t>account data, ownership checks, and retention controls.</a:t>
+              <a:t>data make personalized suggestions usable.</a:t>
             </a:r>
           </a:p>
         </p:txBody>
@@ -10662,7 +10946,7 @@
                 </a:solidFill>
                 <a:latin typeface="Arial"/>
               </a:rPr>
-              <a:t>Live human service</a:t>
+              <a:t>A human who can finish</a:t>
             </a:r>
           </a:p>
         </p:txBody>
@@ -10704,7 +10988,7 @@
                 </a:solidFill>
                 <a:latin typeface="Arial"/>
               </a:rPr>
-              <a:t>Agent availability, queue ownership, employee inbox,</a:t>
+              <a:t>Live agent queue, full conversation handoff,</a:t>
             </a:r>
           </a:p>
           <a:p>
@@ -10723,7 +11007,7 @@
                 </a:solidFill>
                 <a:latin typeface="Arial"/>
               </a:rPr>
-              <a:t>reply in the same chat, SLA, and escalation outcomes.</a:t>
+              <a:t>reply in the same chat, and service levels.</a:t>
             </a:r>
           </a:p>
         </p:txBody>
@@ -10899,7 +11183,7 @@
                 </a:solidFill>
                 <a:latin typeface="Arial"/>
               </a:rPr>
-              <a:t>Quality + operations</a:t>
+              <a:t>Quality customers can rely on</a:t>
             </a:r>
           </a:p>
         </p:txBody>
@@ -10941,7 +11225,7 @@
                 </a:solidFill>
                 <a:latin typeface="Arial"/>
               </a:rPr>
-              <a:t>Independent bilingual held-out evaluation, security</a:t>
+              <a:t>Independent bilingual evaluation, security,</a:t>
             </a:r>
           </a:p>
           <a:p>
@@ -10960,7 +11244,7 @@
                 </a:solidFill>
                 <a:latin typeface="Arial"/>
               </a:rPr>
-              <a:t>testing, capacity/cost budgets, monitoring, and support.</a:t>
+              <a:t>capacity and cost budgets, and monitoring.</a:t>
             </a:r>
           </a:p>
         </p:txBody>
@@ -11047,7 +11331,7 @@
                 </a:solidFill>
                 <a:latin typeface="Arial"/>
               </a:rPr>
-              <a:t>Now: a working, public judge prototype with verified simulated actions.</a:t>
+              <a:t>Today: a public demo. Next: approved bank systems and live reviewers.</a:t>
             </a:r>
           </a:p>
         </p:txBody>

</xml_diff>

<commit_message>
Refocus pitch deck on product journey and technical value (#38)
</commit_message>
<xml_diff>
--- a/presentation/atlas_factored_hackathon_2026.pptx
+++ b/presentation/atlas_factored_hackathon_2026.pptx
@@ -3479,7 +3479,7 @@
                 </a:solidFill>
                 <a:latin typeface="Arial"/>
               </a:rPr>
-              <a:t>A clearer path from card question</a:t>
+              <a:t>Understand a card. Find a fit.</a:t>
             </a:r>
           </a:p>
           <a:p>
@@ -3498,7 +3498,7 @@
                 </a:solidFill>
                 <a:latin typeface="Arial"/>
               </a:rPr>
-              <a:t>to a verified next step</a:t>
+              <a:t>Take a verified next step.</a:t>
             </a:r>
           </a:p>
         </p:txBody>
@@ -3540,7 +3540,7 @@
                 </a:solidFill>
                 <a:latin typeface="Arial"/>
               </a:rPr>
-              <a:t>Credit-card product information, simulated eligibility,</a:t>
+              <a:t>Bilingual card guidance, simulated eligibility,</a:t>
             </a:r>
           </a:p>
           <a:p>
@@ -3559,7 +3559,7 @@
                 </a:solidFill>
                 <a:latin typeface="Arial"/>
               </a:rPr>
-              <a:t>and human-review handoff in Spanish and Portuguese.</a:t>
+              <a:t>and a path to human review in one conversation.</a:t>
             </a:r>
           </a:p>
         </p:txBody>
@@ -4085,7 +4085,7 @@
                 </a:solidFill>
                 <a:latin typeface="Arial"/>
               </a:rPr>
-              <a:t>01  /  THE CUSTOMER PROBLEM</a:t>
+              <a:t>01  /  THE PRODUCT JOURNEY</a:t>
             </a:r>
           </a:p>
         </p:txBody>
@@ -4127,7 +4127,7 @@
                 </a:solidFill>
                 <a:latin typeface="Arial"/>
               </a:rPr>
-              <a:t>Help a prospective card customer decide with confidence</a:t>
+              <a:t>From a card question to a customer-controlled next step</a:t>
             </a:r>
           </a:p>
         </p:txBody>
@@ -4169,7 +4169,7 @@
                 </a:solidFill>
                 <a:latin typeface="Arial"/>
               </a:rPr>
-              <a:t>A customer can ask natural questions, compare cards, request a simulated precheck, or ask for a person.</a:t>
+              <a:t>Spanish and Portuguese chat helps a visitor understand the offers before choosing whether to act.</a:t>
             </a:r>
           </a:p>
         </p:txBody>
@@ -4183,7 +4183,7 @@
         <p:spPr>
           <a:xfrm>
             <a:off x="512064" y="1938528"/>
-            <a:ext cx="11173968" cy="795528"/>
+            <a:ext cx="11173968" cy="640080"/>
           </a:xfrm>
           <a:prstGeom prst="roundRect">
             <a:avLst>
@@ -4227,8 +4227,8 @@
         </p:nvSpPr>
         <p:spPr>
           <a:xfrm>
-            <a:off x="768096" y="2057400"/>
-            <a:ext cx="10643616" cy="585216"/>
+            <a:off x="768096" y="2121408"/>
+            <a:ext cx="10643616" cy="246888"/>
           </a:xfrm>
           <a:prstGeom prst="rect">
             <a:avLst/>
@@ -4250,88 +4250,27 @@
               </a:spcAft>
             </a:pPr>
             <a:r>
-              <a:rPr sz="1600" b="1">
+              <a:rPr sz="1500" b="1">
                 <a:solidFill>
                   <a:srgbClr val="FFFFFF"/>
                 </a:solidFill>
                 <a:latin typeface="Arial"/>
               </a:rPr>
-              <a:t>Goal: answer prospective card questions with grounded facts,</a:t>
-            </a:r>
-          </a:p>
-          <a:p>
-            <a:pPr algn="l">
-              <a:lnSpc>
-                <a:spcPct val="100000"/>
-              </a:lnSpc>
-              <a:spcAft>
-                <a:spcPts val="0"/>
-              </a:spcAft>
-            </a:pPr>
-            <a:r>
-              <a:rPr sz="1600" b="1">
-                <a:solidFill>
-                  <a:srgbClr val="FFFFFF"/>
-                </a:solidFill>
-                <a:latin typeface="Arial"/>
-              </a:rPr>
-              <a:t>then verify every action the agent claims it took.</a:t>
-            </a:r>
-          </a:p>
-        </p:txBody>
-      </p:sp>
-      <p:sp>
-        <p:nvSpPr>
-          <p:cNvPr id="14" name="TextBox 13"/>
-          <p:cNvSpPr txBox="1"/>
-          <p:nvPr/>
-        </p:nvSpPr>
-        <p:spPr>
-          <a:xfrm>
-            <a:off x="512064" y="2971800"/>
-            <a:ext cx="5349240" cy="274320"/>
-          </a:xfrm>
-          <a:prstGeom prst="rect">
-            <a:avLst/>
-          </a:prstGeom>
-          <a:noFill/>
-        </p:spPr>
-        <p:txBody>
-          <a:bodyPr wrap="square" lIns="0" rIns="0" tIns="0" bIns="0" anchor="t">
-            <a:spAutoFit/>
-          </a:bodyPr>
-          <a:lstStyle/>
-          <a:p>
-            <a:pPr algn="l">
-              <a:lnSpc>
-                <a:spcPct val="100000"/>
-              </a:lnSpc>
-              <a:spcAft>
-                <a:spcPts val="0"/>
-              </a:spcAft>
-            </a:pPr>
-            <a:r>
-              <a:rPr sz="1100" b="1">
-                <a:solidFill>
-                  <a:srgbClr val="176F70"/>
-                </a:solidFill>
-                <a:latin typeface="Arial"/>
-              </a:rPr>
-              <a:t>SUPPLIED DATA  /  WHY WE USE IT</a:t>
-            </a:r>
-          </a:p>
-        </p:txBody>
-      </p:sp>
-      <p:sp>
-        <p:nvSpPr>
-          <p:cNvPr id="15" name="Rounded Rectangle 14"/>
+              <a:t>Clear terms now  ·  relevant choices next  ·  verified status for every mock action</a:t>
+            </a:r>
+          </a:p>
+        </p:txBody>
+      </p:sp>
+      <p:sp>
+        <p:nvSpPr>
+          <p:cNvPr id="14" name="Rounded Rectangle 13"/>
           <p:cNvSpPr/>
           <p:nvPr/>
         </p:nvSpPr>
         <p:spPr>
           <a:xfrm>
-            <a:off x="512064" y="3337560"/>
-            <a:ext cx="5330952" cy="1161288"/>
+            <a:off x="512064" y="2907792"/>
+            <a:ext cx="2029968" cy="1719072"/>
           </a:xfrm>
           <a:prstGeom prst="roundRect">
             <a:avLst>
@@ -4371,14 +4310,14 @@
       </p:sp>
       <p:sp>
         <p:nvSpPr>
-          <p:cNvPr id="16" name="Rounded Rectangle 15"/>
+          <p:cNvPr id="15" name="Rounded Rectangle 14"/>
           <p:cNvSpPr/>
           <p:nvPr/>
         </p:nvSpPr>
         <p:spPr>
           <a:xfrm>
-            <a:off x="667512" y="3502152"/>
-            <a:ext cx="365760" cy="365760"/>
+            <a:off x="658368" y="3063240"/>
+            <a:ext cx="347472" cy="347472"/>
           </a:xfrm>
           <a:prstGeom prst="roundRect">
             <a:avLst>
@@ -4416,14 +4355,14 @@
       </p:sp>
       <p:sp>
         <p:nvSpPr>
-          <p:cNvPr id="17" name="TextBox 16"/>
+          <p:cNvPr id="16" name="TextBox 15"/>
           <p:cNvSpPr txBox="1"/>
           <p:nvPr/>
         </p:nvSpPr>
         <p:spPr>
           <a:xfrm>
-            <a:off x="667512" y="3589020"/>
-            <a:ext cx="365760" cy="109728"/>
+            <a:off x="658368" y="3154680"/>
+            <a:ext cx="347472" cy="109728"/>
           </a:xfrm>
           <a:prstGeom prst="rect">
             <a:avLst/>
@@ -4445,7 +4384,7 @@
               </a:spcAft>
             </a:pPr>
             <a:r>
-              <a:rPr sz="1100" b="1">
+              <a:rPr sz="1050" b="1">
                 <a:solidFill>
                   <a:srgbClr val="112B38"/>
                 </a:solidFill>
@@ -4458,14 +4397,14 @@
       </p:sp>
       <p:sp>
         <p:nvSpPr>
-          <p:cNvPr id="18" name="TextBox 17"/>
+          <p:cNvPr id="17" name="TextBox 16"/>
           <p:cNvSpPr txBox="1"/>
           <p:nvPr/>
         </p:nvSpPr>
         <p:spPr>
           <a:xfrm>
-            <a:off x="1152144" y="3520440"/>
-            <a:ext cx="4553712" cy="237744"/>
+            <a:off x="658368" y="3584448"/>
+            <a:ext cx="1737360" cy="274320"/>
           </a:xfrm>
           <a:prstGeom prst="rect">
             <a:avLst/>
@@ -4487,27 +4426,27 @@
               </a:spcAft>
             </a:pPr>
             <a:r>
-              <a:rPr sz="1400" b="1">
+              <a:rPr sz="1600" b="1">
                 <a:solidFill>
                   <a:srgbClr val="112B38"/>
                 </a:solidFill>
                 <a:latin typeface="Arial"/>
               </a:rPr>
-              <a:t>Campaigns + sends</a:t>
-            </a:r>
-          </a:p>
-        </p:txBody>
-      </p:sp>
-      <p:sp>
-        <p:nvSpPr>
-          <p:cNvPr id="19" name="TextBox 18"/>
+              <a:t>Ask</a:t>
+            </a:r>
+          </a:p>
+        </p:txBody>
+      </p:sp>
+      <p:sp>
+        <p:nvSpPr>
+          <p:cNvPr id="18" name="TextBox 17"/>
           <p:cNvSpPr txBox="1"/>
           <p:nvPr/>
         </p:nvSpPr>
         <p:spPr>
           <a:xfrm>
-            <a:off x="1152144" y="3840480"/>
-            <a:ext cx="4526280" cy="576072"/>
+            <a:off x="658368" y="3977639"/>
+            <a:ext cx="1737360" cy="502920"/>
           </a:xfrm>
           <a:prstGeom prst="rect">
             <a:avLst/>
@@ -4535,7 +4474,7 @@
                 </a:solidFill>
                 <a:latin typeface="Arial"/>
               </a:rPr>
-              <a:t>MARKETING_CAMPAIGNS + CAMPAIGN_SENDS: 52 generic</a:t>
+              <a:t>Fees and benefits</a:t>
             </a:r>
           </a:p>
           <a:p>
@@ -4554,8 +4493,55 @@
                 </a:solidFill>
                 <a:latin typeface="Arial"/>
               </a:rPr>
-              <a:t>credit campaigns; interest and entry context, not sales.</a:t>
-            </a:r>
+              <a:t>in natural language</a:t>
+            </a:r>
+          </a:p>
+        </p:txBody>
+      </p:sp>
+      <p:sp>
+        <p:nvSpPr>
+          <p:cNvPr id="19" name="Rounded Rectangle 18"/>
+          <p:cNvSpPr/>
+          <p:nvPr/>
+        </p:nvSpPr>
+        <p:spPr>
+          <a:xfrm>
+            <a:off x="2798064" y="2907792"/>
+            <a:ext cx="2029968" cy="1719072"/>
+          </a:xfrm>
+          <a:prstGeom prst="roundRect">
+            <a:avLst>
+              <a:gd name="adj" fmla="val 12000"/>
+            </a:avLst>
+          </a:prstGeom>
+          <a:solidFill>
+            <a:srgbClr val="E8F2F6"/>
+          </a:solidFill>
+          <a:ln w="12700">
+            <a:solidFill>
+              <a:srgbClr val="D7E3E1"/>
+            </a:solidFill>
+          </a:ln>
+        </p:spPr>
+        <p:style>
+          <a:lnRef idx="1">
+            <a:schemeClr val="accent1"/>
+          </a:lnRef>
+          <a:fillRef idx="3">
+            <a:schemeClr val="accent1"/>
+          </a:fillRef>
+          <a:effectRef idx="2">
+            <a:schemeClr val="accent1"/>
+          </a:effectRef>
+          <a:fontRef idx="minor">
+            <a:schemeClr val="lt1"/>
+          </a:fontRef>
+        </p:style>
+        <p:txBody>
+          <a:bodyPr rtlCol="0" anchor="ctr"/>
+          <a:lstStyle/>
+          <a:p>
+            <a:pPr algn="ctr"/>
           </a:p>
         </p:txBody>
       </p:sp>
@@ -4567,8 +4553,198 @@
         </p:nvSpPr>
         <p:spPr>
           <a:xfrm>
-            <a:off x="512064" y="4617720"/>
-            <a:ext cx="5330952" cy="1161288"/>
+            <a:off x="2944368" y="3063240"/>
+            <a:ext cx="347472" cy="347472"/>
+          </a:xfrm>
+          <a:prstGeom prst="roundRect">
+            <a:avLst>
+              <a:gd name="adj" fmla="val 12000"/>
+            </a:avLst>
+          </a:prstGeom>
+          <a:solidFill>
+            <a:srgbClr val="D5F377"/>
+          </a:solidFill>
+          <a:ln>
+            <a:noFill/>
+          </a:ln>
+        </p:spPr>
+        <p:style>
+          <a:lnRef idx="1">
+            <a:schemeClr val="accent1"/>
+          </a:lnRef>
+          <a:fillRef idx="3">
+            <a:schemeClr val="accent1"/>
+          </a:fillRef>
+          <a:effectRef idx="2">
+            <a:schemeClr val="accent1"/>
+          </a:effectRef>
+          <a:fontRef idx="minor">
+            <a:schemeClr val="lt1"/>
+          </a:fontRef>
+        </p:style>
+        <p:txBody>
+          <a:bodyPr rtlCol="0" anchor="ctr"/>
+          <a:lstStyle/>
+          <a:p>
+            <a:pPr algn="ctr"/>
+          </a:p>
+        </p:txBody>
+      </p:sp>
+      <p:sp>
+        <p:nvSpPr>
+          <p:cNvPr id="21" name="TextBox 20"/>
+          <p:cNvSpPr txBox="1"/>
+          <p:nvPr/>
+        </p:nvSpPr>
+        <p:spPr>
+          <a:xfrm>
+            <a:off x="2944368" y="3154680"/>
+            <a:ext cx="347472" cy="109728"/>
+          </a:xfrm>
+          <a:prstGeom prst="rect">
+            <a:avLst/>
+          </a:prstGeom>
+          <a:noFill/>
+        </p:spPr>
+        <p:txBody>
+          <a:bodyPr wrap="square" lIns="0" rIns="0" tIns="0" bIns="0" anchor="t">
+            <a:spAutoFit/>
+          </a:bodyPr>
+          <a:lstStyle/>
+          <a:p>
+            <a:pPr algn="ctr">
+              <a:lnSpc>
+                <a:spcPct val="100000"/>
+              </a:lnSpc>
+              <a:spcAft>
+                <a:spcPts val="0"/>
+              </a:spcAft>
+            </a:pPr>
+            <a:r>
+              <a:rPr sz="1050" b="1">
+                <a:solidFill>
+                  <a:srgbClr val="112B38"/>
+                </a:solidFill>
+                <a:latin typeface="Arial"/>
+              </a:rPr>
+              <a:t>2</a:t>
+            </a:r>
+          </a:p>
+        </p:txBody>
+      </p:sp>
+      <p:sp>
+        <p:nvSpPr>
+          <p:cNvPr id="22" name="TextBox 21"/>
+          <p:cNvSpPr txBox="1"/>
+          <p:nvPr/>
+        </p:nvSpPr>
+        <p:spPr>
+          <a:xfrm>
+            <a:off x="2944368" y="3584448"/>
+            <a:ext cx="1737360" cy="274320"/>
+          </a:xfrm>
+          <a:prstGeom prst="rect">
+            <a:avLst/>
+          </a:prstGeom>
+          <a:noFill/>
+        </p:spPr>
+        <p:txBody>
+          <a:bodyPr wrap="square" lIns="0" rIns="0" tIns="0" bIns="0" anchor="t">
+            <a:spAutoFit/>
+          </a:bodyPr>
+          <a:lstStyle/>
+          <a:p>
+            <a:pPr algn="l">
+              <a:lnSpc>
+                <a:spcPct val="100000"/>
+              </a:lnSpc>
+              <a:spcAft>
+                <a:spcPts val="0"/>
+              </a:spcAft>
+            </a:pPr>
+            <a:r>
+              <a:rPr sz="1600" b="1">
+                <a:solidFill>
+                  <a:srgbClr val="112B38"/>
+                </a:solidFill>
+                <a:latin typeface="Arial"/>
+              </a:rPr>
+              <a:t>Compare</a:t>
+            </a:r>
+          </a:p>
+        </p:txBody>
+      </p:sp>
+      <p:sp>
+        <p:nvSpPr>
+          <p:cNvPr id="23" name="TextBox 22"/>
+          <p:cNvSpPr txBox="1"/>
+          <p:nvPr/>
+        </p:nvSpPr>
+        <p:spPr>
+          <a:xfrm>
+            <a:off x="2944368" y="3977639"/>
+            <a:ext cx="1737360" cy="502920"/>
+          </a:xfrm>
+          <a:prstGeom prst="rect">
+            <a:avLst/>
+          </a:prstGeom>
+          <a:noFill/>
+        </p:spPr>
+        <p:txBody>
+          <a:bodyPr wrap="square" lIns="0" rIns="0" tIns="0" bIns="0" anchor="t">
+            <a:spAutoFit/>
+          </a:bodyPr>
+          <a:lstStyle/>
+          <a:p>
+            <a:pPr algn="l">
+              <a:lnSpc>
+                <a:spcPct val="100000"/>
+              </a:lnSpc>
+              <a:spcAft>
+                <a:spcPts val="0"/>
+              </a:spcAft>
+            </a:pPr>
+            <a:r>
+              <a:rPr sz="1030" b="0">
+                <a:solidFill>
+                  <a:srgbClr val="617780"/>
+                </a:solidFill>
+                <a:latin typeface="Arial"/>
+              </a:rPr>
+              <a:t>See options and</a:t>
+            </a:r>
+          </a:p>
+          <a:p>
+            <a:pPr algn="l">
+              <a:lnSpc>
+                <a:spcPct val="100000"/>
+              </a:lnSpc>
+              <a:spcAft>
+                <a:spcPts val="0"/>
+              </a:spcAft>
+            </a:pPr>
+            <a:r>
+              <a:rPr sz="1030" b="0">
+                <a:solidFill>
+                  <a:srgbClr val="617780"/>
+                </a:solidFill>
+                <a:latin typeface="Arial"/>
+              </a:rPr>
+              <a:t>their trade-offs</a:t>
+            </a:r>
+          </a:p>
+        </p:txBody>
+      </p:sp>
+      <p:sp>
+        <p:nvSpPr>
+          <p:cNvPr id="24" name="Rounded Rectangle 23"/>
+          <p:cNvSpPr/>
+          <p:nvPr/>
+        </p:nvSpPr>
+        <p:spPr>
+          <a:xfrm>
+            <a:off x="5084064" y="2907792"/>
+            <a:ext cx="2029968" cy="1719072"/>
           </a:xfrm>
           <a:prstGeom prst="roundRect">
             <a:avLst>
@@ -4608,14 +4784,14 @@
       </p:sp>
       <p:sp>
         <p:nvSpPr>
-          <p:cNvPr id="21" name="Rounded Rectangle 20"/>
+          <p:cNvPr id="25" name="Rounded Rectangle 24"/>
           <p:cNvSpPr/>
           <p:nvPr/>
         </p:nvSpPr>
         <p:spPr>
           <a:xfrm>
-            <a:off x="667512" y="4782312"/>
-            <a:ext cx="365760" cy="365760"/>
+            <a:off x="5230368" y="3063240"/>
+            <a:ext cx="347472" cy="347472"/>
           </a:xfrm>
           <a:prstGeom prst="roundRect">
             <a:avLst>
@@ -4653,14 +4829,14 @@
       </p:sp>
       <p:sp>
         <p:nvSpPr>
-          <p:cNvPr id="22" name="TextBox 21"/>
+          <p:cNvPr id="26" name="TextBox 25"/>
           <p:cNvSpPr txBox="1"/>
           <p:nvPr/>
         </p:nvSpPr>
         <p:spPr>
           <a:xfrm>
-            <a:off x="667512" y="4869180"/>
-            <a:ext cx="365760" cy="109728"/>
+            <a:off x="5230368" y="3154680"/>
+            <a:ext cx="347472" cy="109728"/>
           </a:xfrm>
           <a:prstGeom prst="rect">
             <a:avLst/>
@@ -4682,27 +4858,27 @@
               </a:spcAft>
             </a:pPr>
             <a:r>
-              <a:rPr sz="1100" b="1">
+              <a:rPr sz="1050" b="1">
                 <a:solidFill>
                   <a:srgbClr val="112B38"/>
                 </a:solidFill>
                 <a:latin typeface="Arial"/>
               </a:rPr>
-              <a:t>2</a:t>
-            </a:r>
-          </a:p>
-        </p:txBody>
-      </p:sp>
-      <p:sp>
-        <p:nvSpPr>
-          <p:cNvPr id="23" name="TextBox 22"/>
+              <a:t>3</a:t>
+            </a:r>
+          </a:p>
+        </p:txBody>
+      </p:sp>
+      <p:sp>
+        <p:nvSpPr>
+          <p:cNvPr id="27" name="TextBox 26"/>
           <p:cNvSpPr txBox="1"/>
           <p:nvPr/>
         </p:nvSpPr>
         <p:spPr>
           <a:xfrm>
-            <a:off x="1152144" y="4800600"/>
-            <a:ext cx="4553712" cy="237744"/>
+            <a:off x="5230368" y="3584448"/>
+            <a:ext cx="1737360" cy="274320"/>
           </a:xfrm>
           <a:prstGeom prst="rect">
             <a:avLst/>
@@ -4724,27 +4900,27 @@
               </a:spcAft>
             </a:pPr>
             <a:r>
-              <a:rPr sz="1400" b="1">
+              <a:rPr sz="1600" b="1">
                 <a:solidFill>
                   <a:srgbClr val="112B38"/>
                 </a:solidFill>
                 <a:latin typeface="Arial"/>
               </a:rPr>
-              <a:t>Customers + products</a:t>
-            </a:r>
-          </a:p>
-        </p:txBody>
-      </p:sp>
-      <p:sp>
-        <p:nvSpPr>
-          <p:cNvPr id="24" name="TextBox 23"/>
+              <a:t>Choose</a:t>
+            </a:r>
+          </a:p>
+        </p:txBody>
+      </p:sp>
+      <p:sp>
+        <p:nvSpPr>
+          <p:cNvPr id="28" name="TextBox 27"/>
           <p:cNvSpPr txBox="1"/>
           <p:nvPr/>
         </p:nvSpPr>
         <p:spPr>
           <a:xfrm>
-            <a:off x="1152144" y="5120640"/>
-            <a:ext cx="4526280" cy="576072"/>
+            <a:off x="5230368" y="3977639"/>
+            <a:ext cx="1737360" cy="502920"/>
           </a:xfrm>
           <a:prstGeom prst="rect">
             <a:avLst/>
@@ -4772,7 +4948,7 @@
                 </a:solidFill>
                 <a:latin typeface="Arial"/>
               </a:rPr>
-              <a:t>CUSTOMERS + PRODUCTS: local scenario profiles, country,</a:t>
+              <a:t>Keep the right card</a:t>
             </a:r>
           </a:p>
           <a:p>
@@ -4791,21 +4967,258 @@
                 </a:solidFill>
                 <a:latin typeface="Arial"/>
               </a:rPr>
-              <a:t>score, income estimate, and existing holdings.</a:t>
-            </a:r>
-          </a:p>
-        </p:txBody>
-      </p:sp>
-      <p:sp>
-        <p:nvSpPr>
-          <p:cNvPr id="25" name="Rounded Rectangle 24"/>
+              <a:t>in context</a:t>
+            </a:r>
+          </a:p>
+        </p:txBody>
+      </p:sp>
+      <p:sp>
+        <p:nvSpPr>
+          <p:cNvPr id="29" name="Rounded Rectangle 28"/>
           <p:cNvSpPr/>
           <p:nvPr/>
         </p:nvSpPr>
         <p:spPr>
           <a:xfrm>
-            <a:off x="6053328" y="3337560"/>
-            <a:ext cx="5632704" cy="1161288"/>
+            <a:off x="7370064" y="2907792"/>
+            <a:ext cx="2029968" cy="1719072"/>
+          </a:xfrm>
+          <a:prstGeom prst="roundRect">
+            <a:avLst>
+              <a:gd name="adj" fmla="val 12000"/>
+            </a:avLst>
+          </a:prstGeom>
+          <a:solidFill>
+            <a:srgbClr val="E9F4EE"/>
+          </a:solidFill>
+          <a:ln w="12700">
+            <a:solidFill>
+              <a:srgbClr val="D7E3E1"/>
+            </a:solidFill>
+          </a:ln>
+        </p:spPr>
+        <p:style>
+          <a:lnRef idx="1">
+            <a:schemeClr val="accent1"/>
+          </a:lnRef>
+          <a:fillRef idx="3">
+            <a:schemeClr val="accent1"/>
+          </a:fillRef>
+          <a:effectRef idx="2">
+            <a:schemeClr val="accent1"/>
+          </a:effectRef>
+          <a:fontRef idx="minor">
+            <a:schemeClr val="lt1"/>
+          </a:fontRef>
+        </p:style>
+        <p:txBody>
+          <a:bodyPr rtlCol="0" anchor="ctr"/>
+          <a:lstStyle/>
+          <a:p>
+            <a:pPr algn="ctr"/>
+          </a:p>
+        </p:txBody>
+      </p:sp>
+      <p:sp>
+        <p:nvSpPr>
+          <p:cNvPr id="30" name="Rounded Rectangle 29"/>
+          <p:cNvSpPr/>
+          <p:nvPr/>
+        </p:nvSpPr>
+        <p:spPr>
+          <a:xfrm>
+            <a:off x="7516368" y="3063240"/>
+            <a:ext cx="347472" cy="347472"/>
+          </a:xfrm>
+          <a:prstGeom prst="roundRect">
+            <a:avLst>
+              <a:gd name="adj" fmla="val 12000"/>
+            </a:avLst>
+          </a:prstGeom>
+          <a:solidFill>
+            <a:srgbClr val="D5F377"/>
+          </a:solidFill>
+          <a:ln>
+            <a:noFill/>
+          </a:ln>
+        </p:spPr>
+        <p:style>
+          <a:lnRef idx="1">
+            <a:schemeClr val="accent1"/>
+          </a:lnRef>
+          <a:fillRef idx="3">
+            <a:schemeClr val="accent1"/>
+          </a:fillRef>
+          <a:effectRef idx="2">
+            <a:schemeClr val="accent1"/>
+          </a:effectRef>
+          <a:fontRef idx="minor">
+            <a:schemeClr val="lt1"/>
+          </a:fontRef>
+        </p:style>
+        <p:txBody>
+          <a:bodyPr rtlCol="0" anchor="ctr"/>
+          <a:lstStyle/>
+          <a:p>
+            <a:pPr algn="ctr"/>
+          </a:p>
+        </p:txBody>
+      </p:sp>
+      <p:sp>
+        <p:nvSpPr>
+          <p:cNvPr id="31" name="TextBox 30"/>
+          <p:cNvSpPr txBox="1"/>
+          <p:nvPr/>
+        </p:nvSpPr>
+        <p:spPr>
+          <a:xfrm>
+            <a:off x="7516368" y="3154680"/>
+            <a:ext cx="347472" cy="109728"/>
+          </a:xfrm>
+          <a:prstGeom prst="rect">
+            <a:avLst/>
+          </a:prstGeom>
+          <a:noFill/>
+        </p:spPr>
+        <p:txBody>
+          <a:bodyPr wrap="square" lIns="0" rIns="0" tIns="0" bIns="0" anchor="t">
+            <a:spAutoFit/>
+          </a:bodyPr>
+          <a:lstStyle/>
+          <a:p>
+            <a:pPr algn="ctr">
+              <a:lnSpc>
+                <a:spcPct val="100000"/>
+              </a:lnSpc>
+              <a:spcAft>
+                <a:spcPts val="0"/>
+              </a:spcAft>
+            </a:pPr>
+            <a:r>
+              <a:rPr sz="1050" b="1">
+                <a:solidFill>
+                  <a:srgbClr val="112B38"/>
+                </a:solidFill>
+                <a:latin typeface="Arial"/>
+              </a:rPr>
+              <a:t>4</a:t>
+            </a:r>
+          </a:p>
+        </p:txBody>
+      </p:sp>
+      <p:sp>
+        <p:nvSpPr>
+          <p:cNvPr id="32" name="TextBox 31"/>
+          <p:cNvSpPr txBox="1"/>
+          <p:nvPr/>
+        </p:nvSpPr>
+        <p:spPr>
+          <a:xfrm>
+            <a:off x="7516368" y="3584448"/>
+            <a:ext cx="1737360" cy="274320"/>
+          </a:xfrm>
+          <a:prstGeom prst="rect">
+            <a:avLst/>
+          </a:prstGeom>
+          <a:noFill/>
+        </p:spPr>
+        <p:txBody>
+          <a:bodyPr wrap="square" lIns="0" rIns="0" tIns="0" bIns="0" anchor="t">
+            <a:spAutoFit/>
+          </a:bodyPr>
+          <a:lstStyle/>
+          <a:p>
+            <a:pPr algn="l">
+              <a:lnSpc>
+                <a:spcPct val="100000"/>
+              </a:lnSpc>
+              <a:spcAft>
+                <a:spcPts val="0"/>
+              </a:spcAft>
+            </a:pPr>
+            <a:r>
+              <a:rPr sz="1600" b="1">
+                <a:solidFill>
+                  <a:srgbClr val="112B38"/>
+                </a:solidFill>
+                <a:latin typeface="Arial"/>
+              </a:rPr>
+              <a:t>Consent</a:t>
+            </a:r>
+          </a:p>
+        </p:txBody>
+      </p:sp>
+      <p:sp>
+        <p:nvSpPr>
+          <p:cNvPr id="33" name="TextBox 32"/>
+          <p:cNvSpPr txBox="1"/>
+          <p:nvPr/>
+        </p:nvSpPr>
+        <p:spPr>
+          <a:xfrm>
+            <a:off x="7516368" y="3977639"/>
+            <a:ext cx="1737360" cy="502920"/>
+          </a:xfrm>
+          <a:prstGeom prst="rect">
+            <a:avLst/>
+          </a:prstGeom>
+          <a:noFill/>
+        </p:spPr>
+        <p:txBody>
+          <a:bodyPr wrap="square" lIns="0" rIns="0" tIns="0" bIns="0" anchor="t">
+            <a:spAutoFit/>
+          </a:bodyPr>
+          <a:lstStyle/>
+          <a:p>
+            <a:pPr algn="l">
+              <a:lnSpc>
+                <a:spcPct val="100000"/>
+              </a:lnSpc>
+              <a:spcAft>
+                <a:spcPts val="0"/>
+              </a:spcAft>
+            </a:pPr>
+            <a:r>
+              <a:rPr sz="1030" b="0">
+                <a:solidFill>
+                  <a:srgbClr val="617780"/>
+                </a:solidFill>
+                <a:latin typeface="Arial"/>
+              </a:rPr>
+              <a:t>Allow an optional</a:t>
+            </a:r>
+          </a:p>
+          <a:p>
+            <a:pPr algn="l">
+              <a:lnSpc>
+                <a:spcPct val="100000"/>
+              </a:lnSpc>
+              <a:spcAft>
+                <a:spcPts val="0"/>
+              </a:spcAft>
+            </a:pPr>
+            <a:r>
+              <a:rPr sz="1030" b="0">
+                <a:solidFill>
+                  <a:srgbClr val="617780"/>
+                </a:solidFill>
+                <a:latin typeface="Arial"/>
+              </a:rPr>
+              <a:t>card-specific precheck</a:t>
+            </a:r>
+          </a:p>
+        </p:txBody>
+      </p:sp>
+      <p:sp>
+        <p:nvSpPr>
+          <p:cNvPr id="34" name="Rounded Rectangle 33"/>
+          <p:cNvSpPr/>
+          <p:nvPr/>
+        </p:nvSpPr>
+        <p:spPr>
+          <a:xfrm>
+            <a:off x="9656064" y="2907792"/>
+            <a:ext cx="2029968" cy="1719072"/>
           </a:xfrm>
           <a:prstGeom prst="roundRect">
             <a:avLst>
@@ -4845,14 +5258,14 @@
       </p:sp>
       <p:sp>
         <p:nvSpPr>
-          <p:cNvPr id="26" name="Rounded Rectangle 25"/>
+          <p:cNvPr id="35" name="Rounded Rectangle 34"/>
           <p:cNvSpPr/>
           <p:nvPr/>
         </p:nvSpPr>
         <p:spPr>
           <a:xfrm>
-            <a:off x="6208776" y="3502152"/>
-            <a:ext cx="365760" cy="365760"/>
+            <a:off x="9802368" y="3063240"/>
+            <a:ext cx="347472" cy="347472"/>
           </a:xfrm>
           <a:prstGeom prst="roundRect">
             <a:avLst>
@@ -4890,14 +5303,14 @@
       </p:sp>
       <p:sp>
         <p:nvSpPr>
-          <p:cNvPr id="27" name="TextBox 26"/>
+          <p:cNvPr id="36" name="TextBox 35"/>
           <p:cNvSpPr txBox="1"/>
           <p:nvPr/>
         </p:nvSpPr>
         <p:spPr>
           <a:xfrm>
-            <a:off x="6208776" y="3589020"/>
-            <a:ext cx="365760" cy="109728"/>
+            <a:off x="9802368" y="3154680"/>
+            <a:ext cx="347472" cy="109728"/>
           </a:xfrm>
           <a:prstGeom prst="rect">
             <a:avLst/>
@@ -4919,27 +5332,27 @@
               </a:spcAft>
             </a:pPr>
             <a:r>
-              <a:rPr sz="1100" b="1">
+              <a:rPr sz="1050" b="1">
                 <a:solidFill>
                   <a:srgbClr val="112B38"/>
                 </a:solidFill>
                 <a:latin typeface="Arial"/>
               </a:rPr>
-              <a:t>3</a:t>
-            </a:r>
-          </a:p>
-        </p:txBody>
-      </p:sp>
-      <p:sp>
-        <p:nvSpPr>
-          <p:cNvPr id="28" name="TextBox 27"/>
+              <a:t>5</a:t>
+            </a:r>
+          </a:p>
+        </p:txBody>
+      </p:sp>
+      <p:sp>
+        <p:nvSpPr>
+          <p:cNvPr id="37" name="TextBox 36"/>
           <p:cNvSpPr txBox="1"/>
           <p:nvPr/>
         </p:nvSpPr>
         <p:spPr>
           <a:xfrm>
-            <a:off x="6693408" y="3520440"/>
-            <a:ext cx="4855464" cy="237744"/>
+            <a:off x="9802368" y="3584448"/>
+            <a:ext cx="1737360" cy="274320"/>
           </a:xfrm>
           <a:prstGeom prst="rect">
             <a:avLst/>
@@ -4961,27 +5374,27 @@
               </a:spcAft>
             </a:pPr>
             <a:r>
-              <a:rPr sz="1400" b="1">
+              <a:rPr sz="1600" b="1">
                 <a:solidFill>
                   <a:srgbClr val="112B38"/>
                 </a:solidFill>
                 <a:latin typeface="Arial"/>
               </a:rPr>
-              <a:t>Service agents + transcripts</a:t>
-            </a:r>
-          </a:p>
-        </p:txBody>
-      </p:sp>
-      <p:sp>
-        <p:nvSpPr>
-          <p:cNvPr id="29" name="TextBox 28"/>
+              <a:t>Next step</a:t>
+            </a:r>
+          </a:p>
+        </p:txBody>
+      </p:sp>
+      <p:sp>
+        <p:nvSpPr>
+          <p:cNvPr id="38" name="TextBox 37"/>
           <p:cNvSpPr txBox="1"/>
           <p:nvPr/>
         </p:nvSpPr>
         <p:spPr>
           <a:xfrm>
-            <a:off x="6693408" y="3840480"/>
-            <a:ext cx="4828032" cy="576072"/>
+            <a:off x="9802368" y="3977639"/>
+            <a:ext cx="1737360" cy="502920"/>
           </a:xfrm>
           <a:prstGeom prst="rect">
             <a:avLst/>
@@ -5009,7 +5422,7 @@
                 </a:solidFill>
                 <a:latin typeface="Arial"/>
               </a:rPr>
-              <a:t>SERVICE_AGENTS: language-based mock routing.</a:t>
+              <a:t>Confirm a mock request</a:t>
             </a:r>
           </a:p>
           <a:p>
@@ -5028,21 +5441,21 @@
                 </a:solidFill>
                 <a:latin typeface="Arial"/>
               </a:rPr>
-              <a:t>CALL_TRANSCRIPTS: Spanish tone, not facts.</a:t>
-            </a:r>
-          </a:p>
-        </p:txBody>
-      </p:sp>
-      <p:sp>
-        <p:nvSpPr>
-          <p:cNvPr id="30" name="Rounded Rectangle 29"/>
+              <a:t>or ask for review</a:t>
+            </a:r>
+          </a:p>
+        </p:txBody>
+      </p:sp>
+      <p:sp>
+        <p:nvSpPr>
+          <p:cNvPr id="39" name="Rounded Rectangle 38"/>
           <p:cNvSpPr/>
           <p:nvPr/>
         </p:nvSpPr>
         <p:spPr>
           <a:xfrm>
-            <a:off x="6053328" y="4617720"/>
-            <a:ext cx="5632704" cy="1161288"/>
+            <a:off x="512064" y="4965192"/>
+            <a:ext cx="11173968" cy="557784"/>
           </a:xfrm>
           <a:prstGeom prst="roundRect">
             <a:avLst>
@@ -5082,59 +5495,14 @@
       </p:sp>
       <p:sp>
         <p:nvSpPr>
-          <p:cNvPr id="31" name="Rounded Rectangle 30"/>
-          <p:cNvSpPr/>
-          <p:nvPr/>
-        </p:nvSpPr>
-        <p:spPr>
-          <a:xfrm>
-            <a:off x="6208776" y="4782312"/>
-            <a:ext cx="365760" cy="365760"/>
-          </a:xfrm>
-          <a:prstGeom prst="roundRect">
-            <a:avLst>
-              <a:gd name="adj" fmla="val 12000"/>
-            </a:avLst>
-          </a:prstGeom>
-          <a:solidFill>
-            <a:srgbClr val="D5F377"/>
-          </a:solidFill>
-          <a:ln>
-            <a:noFill/>
-          </a:ln>
-        </p:spPr>
-        <p:style>
-          <a:lnRef idx="1">
-            <a:schemeClr val="accent1"/>
-          </a:lnRef>
-          <a:fillRef idx="3">
-            <a:schemeClr val="accent1"/>
-          </a:fillRef>
-          <a:effectRef idx="2">
-            <a:schemeClr val="accent1"/>
-          </a:effectRef>
-          <a:fontRef idx="minor">
-            <a:schemeClr val="lt1"/>
-          </a:fontRef>
-        </p:style>
-        <p:txBody>
-          <a:bodyPr rtlCol="0" anchor="ctr"/>
-          <a:lstStyle/>
-          <a:p>
-            <a:pPr algn="ctr"/>
-          </a:p>
-        </p:txBody>
-      </p:sp>
-      <p:sp>
-        <p:nvSpPr>
-          <p:cNvPr id="32" name="TextBox 31"/>
+          <p:cNvPr id="40" name="TextBox 39"/>
           <p:cNvSpPr txBox="1"/>
           <p:nvPr/>
         </p:nvSpPr>
         <p:spPr>
           <a:xfrm>
-            <a:off x="6208776" y="4869180"/>
-            <a:ext cx="365760" cy="109728"/>
+            <a:off x="713232" y="5129784"/>
+            <a:ext cx="10789920" cy="228600"/>
           </a:xfrm>
           <a:prstGeom prst="rect">
             <a:avLst/>
@@ -5147,36 +5515,36 @@
           </a:bodyPr>
           <a:lstStyle/>
           <a:p>
-            <a:pPr algn="ctr">
-              <a:lnSpc>
-                <a:spcPct val="100000"/>
-              </a:lnSpc>
-              <a:spcAft>
-                <a:spcPts val="0"/>
-              </a:spcAft>
-            </a:pPr>
-            <a:r>
-              <a:rPr sz="1100" b="1">
-                <a:solidFill>
-                  <a:srgbClr val="112B38"/>
-                </a:solidFill>
-                <a:latin typeface="Arial"/>
-              </a:rPr>
-              <a:t>4</a:t>
-            </a:r>
-          </a:p>
-        </p:txBody>
-      </p:sp>
-      <p:sp>
-        <p:nvSpPr>
-          <p:cNvPr id="33" name="TextBox 32"/>
+            <a:pPr algn="l">
+              <a:lnSpc>
+                <a:spcPct val="100000"/>
+              </a:lnSpc>
+              <a:spcAft>
+                <a:spcPts val="0"/>
+              </a:spcAft>
+            </a:pPr>
+            <a:r>
+              <a:rPr sz="1120" b="1">
+                <a:solidFill>
+                  <a:srgbClr val="176F70"/>
+                </a:solidFill>
+                <a:latin typeface="Arial"/>
+              </a:rPr>
+              <a:t>Four choices: Campus for students  ·  Horizon for daily use  ·  Rewards for travel  ·  Summit for premium travel</a:t>
+            </a:r>
+          </a:p>
+        </p:txBody>
+      </p:sp>
+      <p:sp>
+        <p:nvSpPr>
+          <p:cNvPr id="41" name="TextBox 40"/>
           <p:cNvSpPr txBox="1"/>
           <p:nvPr/>
         </p:nvSpPr>
         <p:spPr>
           <a:xfrm>
-            <a:off x="6693408" y="4800600"/>
-            <a:ext cx="4855464" cy="237744"/>
+            <a:off x="512064" y="5733288"/>
+            <a:ext cx="11082528" cy="365760"/>
           </a:xfrm>
           <a:prstGeom prst="rect">
             <a:avLst/>
@@ -5198,116 +5566,32 @@
               </a:spcAft>
             </a:pPr>
             <a:r>
-              <a:rPr sz="1400" b="1">
-                <a:solidFill>
-                  <a:srgbClr val="112B38"/>
-                </a:solidFill>
-                <a:latin typeface="Arial"/>
-              </a:rPr>
-              <a:t>Team-created demo assets</a:t>
-            </a:r>
-          </a:p>
-        </p:txBody>
-      </p:sp>
-      <p:sp>
-        <p:nvSpPr>
-          <p:cNvPr id="34" name="TextBox 33"/>
-          <p:cNvSpPr txBox="1"/>
-          <p:nvPr/>
-        </p:nvSpPr>
-        <p:spPr>
-          <a:xfrm>
-            <a:off x="6693408" y="5120640"/>
-            <a:ext cx="4828032" cy="576072"/>
-          </a:xfrm>
-          <a:prstGeom prst="rect">
-            <a:avLst/>
-          </a:prstGeom>
-          <a:noFill/>
-        </p:spPr>
-        <p:txBody>
-          <a:bodyPr wrap="square" lIns="0" rIns="0" tIns="0" bIns="0" anchor="t">
-            <a:spAutoFit/>
-          </a:bodyPr>
-          <a:lstStyle/>
-          <a:p>
-            <a:pPr algn="l">
-              <a:lnSpc>
-                <a:spcPct val="100000"/>
-              </a:lnSpc>
-              <a:spcAft>
-                <a:spcPts val="0"/>
-              </a:spcAft>
-            </a:pPr>
-            <a:r>
-              <a:rPr sz="1030" b="0">
+              <a:rPr sz="900" b="0">
                 <a:solidFill>
                   <a:srgbClr val="617780"/>
                 </a:solidFill>
                 <a:latin typeface="Arial"/>
               </a:rPr>
-              <a:t>Four offer terms, synthetic policy, fictional public fixtures,</a:t>
-            </a:r>
-          </a:p>
-          <a:p>
-            <a:pPr algn="l">
-              <a:lnSpc>
-                <a:spcPct val="100000"/>
-              </a:lnSpc>
-              <a:spcAft>
-                <a:spcPts val="0"/>
-              </a:spcAft>
-            </a:pPr>
-            <a:r>
-              <a:rPr sz="1030" b="0">
+              <a:t>Data → value: campaigns shape entry; customer/product rows shape local tests; agent records shape mock routing; transcripts guide tone.</a:t>
+            </a:r>
+          </a:p>
+          <a:p>
+            <a:pPr algn="l">
+              <a:lnSpc>
+                <a:spcPct val="100000"/>
+              </a:lnSpc>
+              <a:spcAft>
+                <a:spcPts val="0"/>
+              </a:spcAft>
+            </a:pPr>
+            <a:r>
+              <a:rPr sz="900" b="0">
                 <a:solidFill>
                   <a:srgbClr val="617780"/>
                 </a:solidFill>
                 <a:latin typeface="Arial"/>
               </a:rPr>
-              <a:t>new chat events, and mock application/handoff records.</a:t>
-            </a:r>
-          </a:p>
-        </p:txBody>
-      </p:sp>
-      <p:sp>
-        <p:nvSpPr>
-          <p:cNvPr id="35" name="TextBox 34"/>
-          <p:cNvSpPr txBox="1"/>
-          <p:nvPr/>
-        </p:nvSpPr>
-        <p:spPr>
-          <a:xfrm>
-            <a:off x="512064" y="6044184"/>
-            <a:ext cx="11064240" cy="228600"/>
-          </a:xfrm>
-          <a:prstGeom prst="rect">
-            <a:avLst/>
-          </a:prstGeom>
-          <a:noFill/>
-        </p:spPr>
-        <p:txBody>
-          <a:bodyPr wrap="square" lIns="0" rIns="0" tIns="0" bIns="0" anchor="t">
-            <a:spAutoFit/>
-          </a:bodyPr>
-          <a:lstStyle/>
-          <a:p>
-            <a:pPr algn="l">
-              <a:lnSpc>
-                <a:spcPct val="100000"/>
-              </a:lnSpc>
-              <a:spcAft>
-                <a:spcPts val="0"/>
-              </a:spcAft>
-            </a:pPr>
-            <a:r>
-              <a:rPr sz="950" b="0">
-                <a:solidFill>
-                  <a:srgbClr val="617780"/>
-                </a:solidFill>
-                <a:latin typeface="Arial"/>
-              </a:rPr>
-              <a:t>Evidence boundary: 1.75M sends and 97.8K clicks cover all supplied campaigns; neither proves card acquisition or chatbot demand.</a:t>
+              <a:t>Public fixtures, offers, policy, and actions are team-created. Historical clicks show engagement, not card sales.</a:t>
             </a:r>
           </a:p>
         </p:txBody>
@@ -5706,7 +5990,7 @@
                 </a:solidFill>
                 <a:latin typeface="Arial"/>
               </a:rPr>
-              <a:t>A real conversation in Spanish</a:t>
+              <a:t>See a live card question answered in Spanish</a:t>
             </a:r>
           </a:p>
         </p:txBody>
@@ -5906,7 +6190,7 @@
                 </a:solidFill>
                 <a:latin typeface="Arial"/>
               </a:rPr>
-              <a:t>What this</a:t>
+              <a:t>Customer</a:t>
             </a:r>
           </a:p>
           <a:p>
@@ -5925,7 +6209,7 @@
                 </a:solidFill>
                 <a:latin typeface="Arial"/>
               </a:rPr>
-              <a:t>shows</a:t>
+              <a:t>value</a:t>
             </a:r>
           </a:p>
         </p:txBody>
@@ -6010,7 +6294,7 @@
                 </a:solidFill>
                 <a:latin typeface="Arial"/>
               </a:rPr>
-              <a:t>Maintains the</a:t>
+              <a:t>Selected card</a:t>
             </a:r>
           </a:p>
           <a:p>
@@ -6029,7 +6313,7 @@
                 </a:solidFill>
                 <a:latin typeface="Arial"/>
               </a:rPr>
-              <a:t>selected card</a:t>
+              <a:t>stays in context</a:t>
             </a:r>
           </a:p>
         </p:txBody>
@@ -6071,7 +6355,7 @@
                 </a:solidFill>
                 <a:latin typeface="Arial"/>
               </a:rPr>
-              <a:t>Answers a</a:t>
+              <a:t>Follow-up gets</a:t>
             </a:r>
           </a:p>
           <a:p>
@@ -6090,7 +6374,7 @@
                 </a:solidFill>
                 <a:latin typeface="Arial"/>
               </a:rPr>
-              <a:t>follow-up</a:t>
+              <a:t>an answer</a:t>
             </a:r>
           </a:p>
         </p:txBody>
@@ -6132,7 +6416,7 @@
                 </a:solidFill>
                 <a:latin typeface="Arial"/>
               </a:rPr>
-              <a:t>Displays source</a:t>
+              <a:t>Source IDs make</a:t>
             </a:r>
           </a:p>
           <a:p>
@@ -6151,7 +6435,7 @@
                 </a:solidFill>
                 <a:latin typeface="Arial"/>
               </a:rPr>
-              <a:t>fact IDs</a:t>
+              <a:t>claims traceable</a:t>
             </a:r>
           </a:p>
         </p:txBody>
@@ -6193,7 +6477,7 @@
                 </a:solidFill>
                 <a:latin typeface="Arial"/>
               </a:rPr>
-              <a:t>Live output; not a script</a:t>
+              <a:t>Live fictional-fixture chat</a:t>
             </a:r>
           </a:p>
         </p:txBody>
@@ -6592,7 +6876,7 @@
                 </a:solidFill>
                 <a:latin typeface="Arial"/>
               </a:rPr>
-              <a:t>Claude routes and answers; the service controls actions</a:t>
+              <a:t>How Atlas turns a question into a safe next step</a:t>
             </a:r>
           </a:p>
         </p:txBody>
@@ -6634,7 +6918,7 @@
                 </a:solidFill>
                 <a:latin typeface="Arial"/>
               </a:rPr>
-              <a:t>A bounded intent choice comes before service-owned policy, consent, and durable outcomes.</a:t>
+              <a:t>Each part supports the journey: understand intent, ground facts, protect consent, and verify actions.</a:t>
             </a:r>
           </a:p>
         </p:txBody>
@@ -6723,7 +7007,7 @@
                 </a:solidFill>
                 <a:latin typeface="Arial"/>
               </a:rPr>
-              <a:t>Browser</a:t>
+              <a:t>Customer starts</a:t>
             </a:r>
           </a:p>
         </p:txBody>
@@ -6784,7 +7068,7 @@
                 </a:solidFill>
                 <a:latin typeface="Arial"/>
               </a:rPr>
-              <a:t>Fictional fixture</a:t>
+              <a:t>Fictional demo customer</a:t>
             </a:r>
           </a:p>
         </p:txBody>
@@ -6915,7 +7199,7 @@
                 </a:solidFill>
                 <a:latin typeface="Arial"/>
               </a:rPr>
-              <a:t>HTTPS API + session</a:t>
+              <a:t>Keeps the active card</a:t>
             </a:r>
           </a:p>
           <a:p>
@@ -6934,7 +7218,7 @@
                 </a:solidFill>
                 <a:latin typeface="Arial"/>
               </a:rPr>
-              <a:t>Protected review route</a:t>
+              <a:t>Checks access + limits</a:t>
             </a:r>
           </a:p>
         </p:txBody>
@@ -7023,7 +7307,7 @@
                 </a:solidFill>
                 <a:latin typeface="Arial"/>
               </a:rPr>
-              <a:t>Conversation router</a:t>
+              <a:t>Haiku intent</a:t>
             </a:r>
           </a:p>
         </p:txBody>
@@ -7065,7 +7349,7 @@
                 </a:solidFill>
                 <a:latin typeface="Arial"/>
               </a:rPr>
-              <a:t>Haiku: bounded intent</a:t>
+              <a:t>Fact / compare / apply</a:t>
             </a:r>
           </a:p>
           <a:p>
@@ -7084,7 +7368,7 @@
                 </a:solidFill>
                 <a:latin typeface="Arial"/>
               </a:rPr>
-              <a:t>Service validates session</a:t>
+              <a:t>No private score sent</a:t>
             </a:r>
           </a:p>
         </p:txBody>
@@ -7255,7 +7539,7 @@
                 </a:solidFill>
                 <a:latin typeface="Arial"/>
               </a:rPr>
-              <a:t>DynamoDB state</a:t>
+              <a:t>Durable state</a:t>
             </a:r>
           </a:p>
         </p:txBody>
@@ -7297,7 +7581,7 @@
                 </a:solidFill>
                 <a:latin typeface="Arial"/>
               </a:rPr>
-              <a:t>Sessions + quota</a:t>
+              <a:t>DynamoDB sessions</a:t>
             </a:r>
           </a:p>
           <a:p>
@@ -7316,7 +7600,7 @@
                 </a:solidFill>
                 <a:latin typeface="Arial"/>
               </a:rPr>
-              <a:t>Actions + roster</a:t>
+              <a:t>Mock actions + read-back</a:t>
             </a:r>
           </a:p>
         </p:txBody>
@@ -7447,7 +7731,7 @@
                 </a:solidFill>
                 <a:latin typeface="Arial"/>
               </a:rPr>
-              <a:t>Product answers</a:t>
+              <a:t>Useful answers</a:t>
             </a:r>
           </a:p>
         </p:txBody>
@@ -7508,7 +7792,7 @@
                 </a:solidFill>
                 <a:latin typeface="Arial"/>
               </a:rPr>
-              <a:t>Citations checked; unknown → offer review</a:t>
+              <a:t>Source IDs trace product claims</a:t>
             </a:r>
           </a:p>
         </p:txBody>
@@ -7597,7 +7881,7 @@
                 </a:solidFill>
                 <a:latin typeface="Arial"/>
               </a:rPr>
-              <a:t>Deterministic policy</a:t>
+              <a:t>Controlled suggestion</a:t>
             </a:r>
           </a:p>
         </p:txBody>
@@ -7639,7 +7923,7 @@
                 </a:solidFill>
                 <a:latin typeface="Arial"/>
               </a:rPr>
-              <a:t>Fixture-bound suggestions</a:t>
+              <a:t>Selected fixture → policy suggestion</a:t>
             </a:r>
           </a:p>
           <a:p>
@@ -7658,7 +7942,7 @@
                 </a:solidFill>
                 <a:latin typeface="Arial"/>
               </a:rPr>
-              <a:t>Consented synthetic precheck</a:t>
+              <a:t>Consent → synthetic precheck</a:t>
             </a:r>
           </a:p>
           <a:p>
@@ -7677,7 +7961,7 @@
                 </a:solidFill>
                 <a:latin typeface="Arial"/>
               </a:rPr>
-              <a:t>The model cannot approve credit</a:t>
+              <a:t>No automatic approval</a:t>
             </a:r>
           </a:p>
         </p:txBody>
@@ -7766,7 +8050,7 @@
                 </a:solidFill>
                 <a:latin typeface="Arial"/>
               </a:rPr>
-              <a:t>Verified actions + reviewer</a:t>
+              <a:t>Verified next step</a:t>
             </a:r>
           </a:p>
         </p:txBody>
@@ -7808,7 +8092,7 @@
                 </a:solidFill>
                 <a:latin typeface="Arial"/>
               </a:rPr>
-              <a:t>Confirmation → write once → read back</a:t>
+              <a:t>Separate confirmation → write → read back</a:t>
             </a:r>
           </a:p>
           <a:p>
@@ -7827,7 +8111,7 @@
                 </a:solidFill>
                 <a:latin typeface="Arial"/>
               </a:rPr>
-              <a:t>Application: PENDING_REVIEW</a:t>
+              <a:t>Mock application: PENDING_REVIEW</a:t>
             </a:r>
           </a:p>
           <a:p>
@@ -7933,7 +8217,7 @@
                 </a:solidFill>
                 <a:latin typeface="Arial"/>
               </a:rPr>
-              <a:t>Boundaries: no private profile in model requests  ·  secrets in AWS SSM  ·  sanitized CloudWatch logs  ·  no bank write</a:t>
+              <a:t>Trust: private score stays in the service  ·  card-specific consent gates precheck  ·  read-back gates success claims</a:t>
             </a:r>
           </a:p>
         </p:txBody>
@@ -8332,7 +8616,7 @@
                 </a:solidFill>
                 <a:latin typeface="Arial"/>
               </a:rPr>
-              <a:t>87 automated tests passed; 7/8 live flows met expectations*</a:t>
+              <a:t>A working journey, backed by measured checks</a:t>
             </a:r>
           </a:p>
         </p:txBody>
@@ -8374,7 +8658,7 @@
                 </a:solidFill>
                 <a:latin typeface="Arial"/>
               </a:rPr>
-              <a:t>Current 4 October build · agent-run production smoke checks.</a:t>
+              <a:t>Current 4 October build · product and safety paths checked in production.</a:t>
             </a:r>
           </a:p>
         </p:txBody>
@@ -9318,7 +9602,7 @@
                 </a:solidFill>
                 <a:latin typeface="Arial"/>
               </a:rPr>
-              <a:t>Dated evidence + capacity</a:t>
+              <a:t>Checks behind the demo</a:t>
             </a:r>
           </a:p>
         </p:txBody>
@@ -9970,7 +10254,7 @@
                 </a:solidFill>
                 <a:latin typeface="Arial"/>
               </a:rPr>
-              <a:t>What changes before a customer can rely on it</a:t>
+              <a:t>From judge demo to a bank-ready advisor</a:t>
             </a:r>
           </a:p>
         </p:txBody>
@@ -10012,7 +10296,7 @@
                 </a:solidFill>
                 <a:latin typeface="Arial"/>
               </a:rPr>
-              <a:t>The prototype proves a workflow; a banking deployment needs approved data, live operations, and independent validation.</a:t>
+              <a:t>The same journey can serve real customers when its facts, identity, and human support are bank-operated.</a:t>
             </a:r>
           </a:p>
         </p:txBody>
@@ -10188,7 +10472,7 @@
                 </a:solidFill>
                 <a:latin typeface="Arial"/>
               </a:rPr>
-              <a:t>Approved products + policy</a:t>
+              <a:t>Accurate live offers</a:t>
             </a:r>
           </a:p>
         </p:txBody>
@@ -10230,7 +10514,7 @@
                 </a:solidFill>
                 <a:latin typeface="Arial"/>
               </a:rPr>
-              <a:t>Replace demo offers and thresholds with governed,</a:t>
+              <a:t>Governed card terms and credit policy replace</a:t>
             </a:r>
           </a:p>
           <a:p>
@@ -10249,7 +10533,7 @@
                 </a:solidFill>
                 <a:latin typeface="Arial"/>
               </a:rPr>
-              <a:t>versioned bank terms and credit policy; legal review.</a:t>
+              <a:t>team-created demo offers and thresholds.</a:t>
             </a:r>
           </a:p>
         </p:txBody>
@@ -10425,7 +10709,7 @@
                 </a:solidFill>
                 <a:latin typeface="Arial"/>
               </a:rPr>
-              <a:t>Identity + data permissions</a:t>
+              <a:t>Trusted customer context</a:t>
             </a:r>
           </a:p>
         </p:txBody>
@@ -10467,7 +10751,7 @@
                 </a:solidFill>
                 <a:latin typeface="Arial"/>
               </a:rPr>
-              <a:t>Real customer authentication, consent, current</a:t>
+              <a:t>Verified identity, permission, and current account</a:t>
             </a:r>
           </a:p>
           <a:p>
@@ -10486,7 +10770,7 @@
                 </a:solidFill>
                 <a:latin typeface="Arial"/>
               </a:rPr>
-              <a:t>account data, ownership checks, and retention controls.</a:t>
+              <a:t>data make personalized suggestions usable.</a:t>
             </a:r>
           </a:p>
         </p:txBody>
@@ -10662,7 +10946,7 @@
                 </a:solidFill>
                 <a:latin typeface="Arial"/>
               </a:rPr>
-              <a:t>Live human service</a:t>
+              <a:t>A human who can finish</a:t>
             </a:r>
           </a:p>
         </p:txBody>
@@ -10704,7 +10988,7 @@
                 </a:solidFill>
                 <a:latin typeface="Arial"/>
               </a:rPr>
-              <a:t>Agent availability, queue ownership, employee inbox,</a:t>
+              <a:t>Live agent queue, full conversation handoff,</a:t>
             </a:r>
           </a:p>
           <a:p>
@@ -10723,7 +11007,7 @@
                 </a:solidFill>
                 <a:latin typeface="Arial"/>
               </a:rPr>
-              <a:t>reply in the same chat, SLA, and escalation outcomes.</a:t>
+              <a:t>reply in the same chat, and service levels.</a:t>
             </a:r>
           </a:p>
         </p:txBody>
@@ -10899,7 +11183,7 @@
                 </a:solidFill>
                 <a:latin typeface="Arial"/>
               </a:rPr>
-              <a:t>Quality + operations</a:t>
+              <a:t>Quality customers can rely on</a:t>
             </a:r>
           </a:p>
         </p:txBody>
@@ -10941,7 +11225,7 @@
                 </a:solidFill>
                 <a:latin typeface="Arial"/>
               </a:rPr>
-              <a:t>Independent bilingual held-out evaluation, security</a:t>
+              <a:t>Independent bilingual evaluation, security,</a:t>
             </a:r>
           </a:p>
           <a:p>
@@ -10960,7 +11244,7 @@
                 </a:solidFill>
                 <a:latin typeface="Arial"/>
               </a:rPr>
-              <a:t>testing, capacity/cost budgets, monitoring, and support.</a:t>
+              <a:t>capacity and cost budgets, and monitoring.</a:t>
             </a:r>
           </a:p>
         </p:txBody>
@@ -11047,7 +11331,7 @@
                 </a:solidFill>
                 <a:latin typeface="Arial"/>
               </a:rPr>
-              <a:t>Now: a working, public judge prototype with verified simulated actions.</a:t>
+              <a:t>Today: a public demo. Next: approved bank systems and live reviewers.</a:t>
             </a:r>
           </a:p>
         </p:txBody>

</xml_diff>